<commit_message>
updates through Lecture 9
</commit_message>
<xml_diff>
--- a/Lecture_Slides/PH 123 Lecture 06.pptx
+++ b/Lecture_Slides/PH 123 Lecture 06.pptx
@@ -5,7 +5,7 @@
     <p:sldMasterId id="2147483648" r:id="rId1"/>
   </p:sldMasterIdLst>
   <p:notesMasterIdLst>
-    <p:notesMasterId r:id="rId88"/>
+    <p:notesMasterId r:id="rId90"/>
   </p:notesMasterIdLst>
   <p:sldIdLst>
     <p:sldId id="345" r:id="rId2"/>
@@ -20,8 +20,8 @@
     <p:sldId id="288" r:id="rId11"/>
     <p:sldId id="311" r:id="rId12"/>
     <p:sldId id="290" r:id="rId13"/>
-    <p:sldId id="291" r:id="rId14"/>
-    <p:sldId id="312" r:id="rId15"/>
+    <p:sldId id="312" r:id="rId14"/>
+    <p:sldId id="291" r:id="rId15"/>
     <p:sldId id="321" r:id="rId16"/>
     <p:sldId id="323" r:id="rId17"/>
     <p:sldId id="354" r:id="rId18"/>
@@ -46,54 +46,56 @@
     <p:sldId id="329" r:id="rId37"/>
     <p:sldId id="330" r:id="rId38"/>
     <p:sldId id="331" r:id="rId39"/>
-    <p:sldId id="332" r:id="rId40"/>
-    <p:sldId id="333" r:id="rId41"/>
-    <p:sldId id="334" r:id="rId42"/>
-    <p:sldId id="335" r:id="rId43"/>
-    <p:sldId id="304" r:id="rId44"/>
-    <p:sldId id="368" r:id="rId45"/>
-    <p:sldId id="305" r:id="rId46"/>
-    <p:sldId id="306" r:id="rId47"/>
-    <p:sldId id="307" r:id="rId48"/>
-    <p:sldId id="308" r:id="rId49"/>
-    <p:sldId id="309" r:id="rId50"/>
-    <p:sldId id="261" r:id="rId51"/>
-    <p:sldId id="262" r:id="rId52"/>
-    <p:sldId id="263" r:id="rId53"/>
-    <p:sldId id="265" r:id="rId54"/>
-    <p:sldId id="363" r:id="rId55"/>
-    <p:sldId id="364" r:id="rId56"/>
-    <p:sldId id="259" r:id="rId57"/>
-    <p:sldId id="264" r:id="rId58"/>
-    <p:sldId id="365" r:id="rId59"/>
-    <p:sldId id="366" r:id="rId60"/>
-    <p:sldId id="266" r:id="rId61"/>
-    <p:sldId id="346" r:id="rId62"/>
-    <p:sldId id="362" r:id="rId63"/>
-    <p:sldId id="286" r:id="rId64"/>
-    <p:sldId id="292" r:id="rId65"/>
-    <p:sldId id="313" r:id="rId66"/>
-    <p:sldId id="293" r:id="rId67"/>
-    <p:sldId id="294" r:id="rId68"/>
-    <p:sldId id="295" r:id="rId69"/>
-    <p:sldId id="296" r:id="rId70"/>
-    <p:sldId id="297" r:id="rId71"/>
-    <p:sldId id="298" r:id="rId72"/>
-    <p:sldId id="314" r:id="rId73"/>
-    <p:sldId id="315" r:id="rId74"/>
-    <p:sldId id="316" r:id="rId75"/>
-    <p:sldId id="317" r:id="rId76"/>
-    <p:sldId id="299" r:id="rId77"/>
-    <p:sldId id="300" r:id="rId78"/>
-    <p:sldId id="301" r:id="rId79"/>
-    <p:sldId id="302" r:id="rId80"/>
-    <p:sldId id="336" r:id="rId81"/>
-    <p:sldId id="337" r:id="rId82"/>
-    <p:sldId id="342" r:id="rId83"/>
-    <p:sldId id="343" r:id="rId84"/>
-    <p:sldId id="339" r:id="rId85"/>
-    <p:sldId id="340" r:id="rId86"/>
-    <p:sldId id="284" r:id="rId87"/>
+    <p:sldId id="369" r:id="rId40"/>
+    <p:sldId id="370" r:id="rId41"/>
+    <p:sldId id="332" r:id="rId42"/>
+    <p:sldId id="333" r:id="rId43"/>
+    <p:sldId id="334" r:id="rId44"/>
+    <p:sldId id="335" r:id="rId45"/>
+    <p:sldId id="304" r:id="rId46"/>
+    <p:sldId id="368" r:id="rId47"/>
+    <p:sldId id="305" r:id="rId48"/>
+    <p:sldId id="306" r:id="rId49"/>
+    <p:sldId id="307" r:id="rId50"/>
+    <p:sldId id="308" r:id="rId51"/>
+    <p:sldId id="309" r:id="rId52"/>
+    <p:sldId id="261" r:id="rId53"/>
+    <p:sldId id="262" r:id="rId54"/>
+    <p:sldId id="263" r:id="rId55"/>
+    <p:sldId id="265" r:id="rId56"/>
+    <p:sldId id="363" r:id="rId57"/>
+    <p:sldId id="364" r:id="rId58"/>
+    <p:sldId id="259" r:id="rId59"/>
+    <p:sldId id="264" r:id="rId60"/>
+    <p:sldId id="365" r:id="rId61"/>
+    <p:sldId id="366" r:id="rId62"/>
+    <p:sldId id="266" r:id="rId63"/>
+    <p:sldId id="346" r:id="rId64"/>
+    <p:sldId id="362" r:id="rId65"/>
+    <p:sldId id="286" r:id="rId66"/>
+    <p:sldId id="292" r:id="rId67"/>
+    <p:sldId id="313" r:id="rId68"/>
+    <p:sldId id="293" r:id="rId69"/>
+    <p:sldId id="294" r:id="rId70"/>
+    <p:sldId id="295" r:id="rId71"/>
+    <p:sldId id="296" r:id="rId72"/>
+    <p:sldId id="297" r:id="rId73"/>
+    <p:sldId id="298" r:id="rId74"/>
+    <p:sldId id="314" r:id="rId75"/>
+    <p:sldId id="315" r:id="rId76"/>
+    <p:sldId id="316" r:id="rId77"/>
+    <p:sldId id="317" r:id="rId78"/>
+    <p:sldId id="299" r:id="rId79"/>
+    <p:sldId id="300" r:id="rId80"/>
+    <p:sldId id="301" r:id="rId81"/>
+    <p:sldId id="302" r:id="rId82"/>
+    <p:sldId id="336" r:id="rId83"/>
+    <p:sldId id="337" r:id="rId84"/>
+    <p:sldId id="342" r:id="rId85"/>
+    <p:sldId id="343" r:id="rId86"/>
+    <p:sldId id="339" r:id="rId87"/>
+    <p:sldId id="340" r:id="rId88"/>
+    <p:sldId id="284" r:id="rId89"/>
   </p:sldIdLst>
   <p:sldSz cx="9144000" cy="6858000" type="screen4x3"/>
   <p:notesSz cx="6858000" cy="9144000"/>
@@ -214,7 +216,7 @@
 <file path=ppt/revisionInfo.xml><?xml version="1.0" encoding="utf-8"?>
 <p1510:revInfo xmlns:a="http://schemas.openxmlformats.org/drawingml/2006/main" xmlns:r="http://schemas.openxmlformats.org/officeDocument/2006/relationships" xmlns:p1510="http://schemas.microsoft.com/office/powerpoint/2015/10/main">
   <p1510:revLst>
-    <p1510:client id="{161164B0-73E3-413D-AC9E-BBA2869A21ED}" v="9" dt="2026-04-24T20:16:45.207"/>
+    <p1510:client id="{161164B0-73E3-413D-AC9E-BBA2869A21ED}" v="11" dt="2026-04-27T15:44:36.690"/>
   </p1510:revLst>
 </p1510:revInfo>
 </file>
@@ -223,11 +225,18 @@
 <pc:chgInfo xmlns:a="http://schemas.openxmlformats.org/drawingml/2006/main" xmlns:r="http://schemas.openxmlformats.org/officeDocument/2006/relationships" xmlns:ac="http://schemas.microsoft.com/office/drawing/2013/main/command" xmlns:pc="http://schemas.microsoft.com/office/powerpoint/2013/main/command">
   <pc:docChgLst>
     <pc:chgData name="Lines, Todd" userId="afaf7c3a-e8aa-4568-882a-02ad8f9e19b0" providerId="ADAL" clId="{5FF5AC1B-ABA9-43D7-A1E3-2D92732CD6E2}"/>
-    <pc:docChg chg="undo custSel addSld delSld modSld">
-      <pc:chgData name="Lines, Todd" userId="afaf7c3a-e8aa-4568-882a-02ad8f9e19b0" providerId="ADAL" clId="{5FF5AC1B-ABA9-43D7-A1E3-2D92732CD6E2}" dt="2026-04-24T20:33:12.171" v="62" actId="1076"/>
+    <pc:docChg chg="undo custSel addSld delSld modSld sldOrd">
+      <pc:chgData name="Lines, Todd" userId="afaf7c3a-e8aa-4568-882a-02ad8f9e19b0" providerId="ADAL" clId="{5FF5AC1B-ABA9-43D7-A1E3-2D92732CD6E2}" dt="2026-04-27T15:44:36.687" v="66"/>
       <pc:docMkLst>
         <pc:docMk/>
       </pc:docMkLst>
+      <pc:sldChg chg="ord">
+        <pc:chgData name="Lines, Todd" userId="afaf7c3a-e8aa-4568-882a-02ad8f9e19b0" providerId="ADAL" clId="{5FF5AC1B-ABA9-43D7-A1E3-2D92732CD6E2}" dt="2026-04-27T15:43:26.605" v="64"/>
+        <pc:sldMkLst>
+          <pc:docMk/>
+          <pc:sldMk cId="3767951174" sldId="312"/>
+        </pc:sldMkLst>
+      </pc:sldChg>
       <pc:sldChg chg="delSp modSp mod">
         <pc:chgData name="Lines, Todd" userId="afaf7c3a-e8aa-4568-882a-02ad8f9e19b0" providerId="ADAL" clId="{5FF5AC1B-ABA9-43D7-A1E3-2D92732CD6E2}" dt="2026-04-24T20:16:54.261" v="55" actId="21"/>
         <pc:sldMkLst>
@@ -266,30 +275,6 @@
             <ac:spMk id="11" creationId="{E7585B40-CC23-8828-633D-7F296358D19A}"/>
           </ac:spMkLst>
         </pc:spChg>
-        <pc:picChg chg="del">
-          <ac:chgData name="Lines, Todd" userId="afaf7c3a-e8aa-4568-882a-02ad8f9e19b0" providerId="ADAL" clId="{5FF5AC1B-ABA9-43D7-A1E3-2D92732CD6E2}" dt="2026-04-24T20:16:09.674" v="45" actId="478"/>
-          <ac:picMkLst>
-            <pc:docMk/>
-            <pc:sldMk cId="1643441071" sldId="347"/>
-            <ac:picMk id="2" creationId="{3BDD161A-FF67-C485-9258-A5DFBE8652EF}"/>
-          </ac:picMkLst>
-        </pc:picChg>
-        <pc:picChg chg="del">
-          <ac:chgData name="Lines, Todd" userId="afaf7c3a-e8aa-4568-882a-02ad8f9e19b0" providerId="ADAL" clId="{5FF5AC1B-ABA9-43D7-A1E3-2D92732CD6E2}" dt="2026-04-24T20:16:29.447" v="50" actId="478"/>
-          <ac:picMkLst>
-            <pc:docMk/>
-            <pc:sldMk cId="1643441071" sldId="347"/>
-            <ac:picMk id="3" creationId="{D210F6D0-1984-60DB-37BB-096A9A7F3E3B}"/>
-          </ac:picMkLst>
-        </pc:picChg>
-        <pc:picChg chg="del mod">
-          <ac:chgData name="Lines, Todd" userId="afaf7c3a-e8aa-4568-882a-02ad8f9e19b0" providerId="ADAL" clId="{5FF5AC1B-ABA9-43D7-A1E3-2D92732CD6E2}" dt="2026-04-24T20:16:54.261" v="55" actId="21"/>
-          <ac:picMkLst>
-            <pc:docMk/>
-            <pc:sldMk cId="1643441071" sldId="347"/>
-            <ac:picMk id="8" creationId="{EA45425E-DD19-94FA-FBFC-13DF269603B2}"/>
-          </ac:picMkLst>
-        </pc:picChg>
       </pc:sldChg>
       <pc:sldChg chg="addSp delSp modSp mod">
         <pc:chgData name="Lines, Todd" userId="afaf7c3a-e8aa-4568-882a-02ad8f9e19b0" providerId="ADAL" clId="{5FF5AC1B-ABA9-43D7-A1E3-2D92732CD6E2}" dt="2026-04-24T20:33:12.171" v="62" actId="1076"/>
@@ -297,22 +282,6 @@
           <pc:docMk/>
           <pc:sldMk cId="619843192" sldId="358"/>
         </pc:sldMkLst>
-        <pc:spChg chg="add del">
-          <ac:chgData name="Lines, Todd" userId="afaf7c3a-e8aa-4568-882a-02ad8f9e19b0" providerId="ADAL" clId="{5FF5AC1B-ABA9-43D7-A1E3-2D92732CD6E2}" dt="2026-04-24T20:33:04.519" v="58" actId="22"/>
-          <ac:spMkLst>
-            <pc:docMk/>
-            <pc:sldMk cId="619843192" sldId="358"/>
-            <ac:spMk id="4" creationId="{1DA6E969-146E-E931-71AA-EDFE996DD6BB}"/>
-          </ac:spMkLst>
-        </pc:spChg>
-        <pc:grpChg chg="del">
-          <ac:chgData name="Lines, Todd" userId="afaf7c3a-e8aa-4568-882a-02ad8f9e19b0" providerId="ADAL" clId="{5FF5AC1B-ABA9-43D7-A1E3-2D92732CD6E2}" dt="2026-04-24T20:33:02.362" v="56" actId="478"/>
-          <ac:grpSpMkLst>
-            <pc:docMk/>
-            <pc:sldMk cId="619843192" sldId="358"/>
-            <ac:grpSpMk id="2" creationId="{00000000-0000-0000-0000-000000000000}"/>
-          </ac:grpSpMkLst>
-        </pc:grpChg>
         <pc:picChg chg="add mod">
           <ac:chgData name="Lines, Todd" userId="afaf7c3a-e8aa-4568-882a-02ad8f9e19b0" providerId="ADAL" clId="{5FF5AC1B-ABA9-43D7-A1E3-2D92732CD6E2}" dt="2026-04-24T20:33:12.171" v="62" actId="1076"/>
           <ac:picMkLst>
@@ -321,6 +290,20 @@
             <ac:picMk id="6" creationId="{EAE5FC2A-0A7E-59BF-C54F-818F688A10F7}"/>
           </ac:picMkLst>
         </pc:picChg>
+      </pc:sldChg>
+      <pc:sldChg chg="add">
+        <pc:chgData name="Lines, Todd" userId="afaf7c3a-e8aa-4568-882a-02ad8f9e19b0" providerId="ADAL" clId="{5FF5AC1B-ABA9-43D7-A1E3-2D92732CD6E2}" dt="2026-04-27T15:44:26.554" v="65"/>
+        <pc:sldMkLst>
+          <pc:docMk/>
+          <pc:sldMk cId="2085196998" sldId="369"/>
+        </pc:sldMkLst>
+      </pc:sldChg>
+      <pc:sldChg chg="add">
+        <pc:chgData name="Lines, Todd" userId="afaf7c3a-e8aa-4568-882a-02ad8f9e19b0" providerId="ADAL" clId="{5FF5AC1B-ABA9-43D7-A1E3-2D92732CD6E2}" dt="2026-04-27T15:44:36.687" v="66"/>
+        <pc:sldMkLst>
+          <pc:docMk/>
+          <pc:sldMk cId="3064395866" sldId="370"/>
+        </pc:sldMkLst>
       </pc:sldChg>
     </pc:docChg>
   </pc:docChgLst>
@@ -409,7 +392,7 @@
           <a:p>
             <a:fld id="{DA081139-F0BA-49F9-93A6-6F626C1CF540}" type="datetimeFigureOut">
               <a:rPr lang="en-US" smtClean="0"/>
-              <a:t>4/24/2026</a:t>
+              <a:t>4/27/2026</a:t>
             </a:fld>
             <a:endParaRPr lang="en-US"/>
           </a:p>
@@ -786,7 +769,7 @@
                   <a:spcPct val="0"/>
                 </a:spcAft>
               </a:pPr>
-              <a:t>42</a:t>
+              <a:t>44</a:t>
             </a:fld>
             <a:endParaRPr lang="en-US"/>
           </a:p>
@@ -984,7 +967,7 @@
           <a:p>
             <a:fld id="{EDF140B7-8B0E-44A6-9E20-D5135BF064F6}" type="datetimeFigureOut">
               <a:rPr lang="en-US" smtClean="0"/>
-              <a:t>4/24/2026</a:t>
+              <a:t>4/27/2026</a:t>
             </a:fld>
             <a:endParaRPr lang="en-US"/>
           </a:p>
@@ -1147,7 +1130,7 @@
           <a:p>
             <a:fld id="{EDF140B7-8B0E-44A6-9E20-D5135BF064F6}" type="datetimeFigureOut">
               <a:rPr lang="en-US" smtClean="0"/>
-              <a:t>4/24/2026</a:t>
+              <a:t>4/27/2026</a:t>
             </a:fld>
             <a:endParaRPr lang="en-US"/>
           </a:p>
@@ -1320,7 +1303,7 @@
           <a:p>
             <a:fld id="{EDF140B7-8B0E-44A6-9E20-D5135BF064F6}" type="datetimeFigureOut">
               <a:rPr lang="en-US" smtClean="0"/>
-              <a:t>4/24/2026</a:t>
+              <a:t>4/27/2026</a:t>
             </a:fld>
             <a:endParaRPr lang="en-US"/>
           </a:p>
@@ -1483,7 +1466,7 @@
           <a:p>
             <a:fld id="{EDF140B7-8B0E-44A6-9E20-D5135BF064F6}" type="datetimeFigureOut">
               <a:rPr lang="en-US" smtClean="0"/>
-              <a:t>4/24/2026</a:t>
+              <a:t>4/27/2026</a:t>
             </a:fld>
             <a:endParaRPr lang="en-US"/>
           </a:p>
@@ -1723,7 +1706,7 @@
           <a:p>
             <a:fld id="{EDF140B7-8B0E-44A6-9E20-D5135BF064F6}" type="datetimeFigureOut">
               <a:rPr lang="en-US" smtClean="0"/>
-              <a:t>4/24/2026</a:t>
+              <a:t>4/27/2026</a:t>
             </a:fld>
             <a:endParaRPr lang="en-US"/>
           </a:p>
@@ -2003,7 +1986,7 @@
           <a:p>
             <a:fld id="{EDF140B7-8B0E-44A6-9E20-D5135BF064F6}" type="datetimeFigureOut">
               <a:rPr lang="en-US" smtClean="0"/>
-              <a:t>4/24/2026</a:t>
+              <a:t>4/27/2026</a:t>
             </a:fld>
             <a:endParaRPr lang="en-US"/>
           </a:p>
@@ -2417,7 +2400,7 @@
           <a:p>
             <a:fld id="{EDF140B7-8B0E-44A6-9E20-D5135BF064F6}" type="datetimeFigureOut">
               <a:rPr lang="en-US" smtClean="0"/>
-              <a:t>4/24/2026</a:t>
+              <a:t>4/27/2026</a:t>
             </a:fld>
             <a:endParaRPr lang="en-US"/>
           </a:p>
@@ -2529,7 +2512,7 @@
           <a:p>
             <a:fld id="{EDF140B7-8B0E-44A6-9E20-D5135BF064F6}" type="datetimeFigureOut">
               <a:rPr lang="en-US" smtClean="0"/>
-              <a:t>4/24/2026</a:t>
+              <a:t>4/27/2026</a:t>
             </a:fld>
             <a:endParaRPr lang="en-US"/>
           </a:p>
@@ -2619,7 +2602,7 @@
           <a:p>
             <a:fld id="{EDF140B7-8B0E-44A6-9E20-D5135BF064F6}" type="datetimeFigureOut">
               <a:rPr lang="en-US" smtClean="0"/>
-              <a:t>4/24/2026</a:t>
+              <a:t>4/27/2026</a:t>
             </a:fld>
             <a:endParaRPr lang="en-US"/>
           </a:p>
@@ -2889,7 +2872,7 @@
           <a:p>
             <a:fld id="{EDF140B7-8B0E-44A6-9E20-D5135BF064F6}" type="datetimeFigureOut">
               <a:rPr lang="en-US" smtClean="0"/>
-              <a:t>4/24/2026</a:t>
+              <a:t>4/27/2026</a:t>
             </a:fld>
             <a:endParaRPr lang="en-US"/>
           </a:p>
@@ -3136,7 +3119,7 @@
           <a:p>
             <a:fld id="{EDF140B7-8B0E-44A6-9E20-D5135BF064F6}" type="datetimeFigureOut">
               <a:rPr lang="en-US" smtClean="0"/>
-              <a:t>4/24/2026</a:t>
+              <a:t>4/27/2026</a:t>
             </a:fld>
             <a:endParaRPr lang="en-US"/>
           </a:p>
@@ -3342,7 +3325,7 @@
           <a:p>
             <a:fld id="{EDF140B7-8B0E-44A6-9E20-D5135BF064F6}" type="datetimeFigureOut">
               <a:rPr lang="en-US" smtClean="0"/>
-              <a:t>4/24/2026</a:t>
+              <a:t>4/27/2026</a:t>
             </a:fld>
             <a:endParaRPr lang="en-US"/>
           </a:p>
@@ -4426,131 +4409,6 @@
 </file>
 
 <file path=ppt/slides/slide13.xml><?xml version="1.0" encoding="utf-8"?>
-<p:sld xmlns:a="http://schemas.openxmlformats.org/drawingml/2006/main" xmlns:r="http://schemas.openxmlformats.org/officeDocument/2006/relationships" xmlns:p="http://schemas.openxmlformats.org/presentationml/2006/main">
-  <p:cSld>
-    <p:spTree>
-      <p:nvGrpSpPr>
-        <p:cNvPr id="1" name=""/>
-        <p:cNvGrpSpPr/>
-        <p:nvPr/>
-      </p:nvGrpSpPr>
-      <p:grpSpPr>
-        <a:xfrm>
-          <a:off x="0" y="0"/>
-          <a:ext cx="0" cy="0"/>
-          <a:chOff x="0" y="0"/>
-          <a:chExt cx="0" cy="0"/>
-        </a:xfrm>
-      </p:grpSpPr>
-      <p:sp>
-        <p:nvSpPr>
-          <p:cNvPr id="539649" name="Title 1"/>
-          <p:cNvSpPr>
-            <a:spLocks noGrp="1"/>
-          </p:cNvSpPr>
-          <p:nvPr>
-            <p:ph type="title"/>
-          </p:nvPr>
-        </p:nvSpPr>
-        <p:spPr/>
-        <p:txBody>
-          <a:bodyPr/>
-          <a:lstStyle/>
-          <a:p>
-            <a:r>
-              <a:rPr lang="en-US" dirty="0"/>
-              <a:t>Question 223.4.10  123.22.5</a:t>
-            </a:r>
-          </a:p>
-        </p:txBody>
-      </p:sp>
-      <p:sp>
-        <p:nvSpPr>
-          <p:cNvPr id="539650" name="Content Placeholder 2"/>
-          <p:cNvSpPr>
-            <a:spLocks noGrp="1"/>
-          </p:cNvSpPr>
-          <p:nvPr>
-            <p:ph idx="1"/>
-          </p:nvPr>
-        </p:nvSpPr>
-        <p:spPr/>
-        <p:txBody>
-          <a:bodyPr/>
-          <a:lstStyle/>
-          <a:p>
-            <a:pPr>
-              <a:buFontTx/>
-              <a:buNone/>
-            </a:pPr>
-            <a:r>
-              <a:rPr lang="en-US" dirty="0"/>
-              <a:t>I have 100W of power coming from my speaker. What is the intensity 0.5m from the speaker?</a:t>
-            </a:r>
-          </a:p>
-          <a:p>
-            <a:pPr>
-              <a:buFontTx/>
-              <a:buNone/>
-            </a:pPr>
-            <a:r>
-              <a:rPr lang="en-US" dirty="0"/>
-              <a:t>a) 0.01W</a:t>
-            </a:r>
-          </a:p>
-          <a:p>
-            <a:pPr>
-              <a:buFontTx/>
-              <a:buNone/>
-            </a:pPr>
-            <a:r>
-              <a:rPr lang="en-US" dirty="0"/>
-              <a:t>b) Just under 1W</a:t>
-            </a:r>
-          </a:p>
-          <a:p>
-            <a:pPr>
-              <a:buFontTx/>
-              <a:buNone/>
-            </a:pPr>
-            <a:r>
-              <a:rPr lang="en-US" dirty="0"/>
-              <a:t>c) A little over 10W</a:t>
-            </a:r>
-          </a:p>
-          <a:p>
-            <a:pPr>
-              <a:buFontTx/>
-              <a:buNone/>
-            </a:pPr>
-            <a:r>
-              <a:rPr lang="en-US" dirty="0"/>
-              <a:t>d) A little over 30W</a:t>
-            </a:r>
-          </a:p>
-          <a:p>
-            <a:pPr>
-              <a:buFontTx/>
-              <a:buNone/>
-            </a:pPr>
-            <a:endParaRPr lang="en-US" dirty="0"/>
-          </a:p>
-        </p:txBody>
-      </p:sp>
-    </p:spTree>
-    <p:extLst>
-      <p:ext uri="{BB962C8B-B14F-4D97-AF65-F5344CB8AC3E}">
-        <p14:creationId xmlns:p14="http://schemas.microsoft.com/office/powerpoint/2010/main" val="3337956701"/>
-      </p:ext>
-    </p:extLst>
-  </p:cSld>
-  <p:clrMapOvr>
-    <a:masterClrMapping/>
-  </p:clrMapOvr>
-</p:sld>
-</file>
-
-<file path=ppt/slides/slide14.xml><?xml version="1.0" encoding="utf-8"?>
 <p:sld xmlns:a="http://schemas.openxmlformats.org/drawingml/2006/main" xmlns:r="http://schemas.openxmlformats.org/officeDocument/2006/relationships" xmlns:p="http://schemas.openxmlformats.org/presentationml/2006/main">
   <p:cSld>
     <p:spTree>
@@ -6371,6 +6229,131 @@
     <p:extLst>
       <p:ext uri="{BB962C8B-B14F-4D97-AF65-F5344CB8AC3E}">
         <p14:creationId xmlns:p14="http://schemas.microsoft.com/office/powerpoint/2010/main" val="3767951174"/>
+      </p:ext>
+    </p:extLst>
+  </p:cSld>
+  <p:clrMapOvr>
+    <a:masterClrMapping/>
+  </p:clrMapOvr>
+</p:sld>
+</file>
+
+<file path=ppt/slides/slide14.xml><?xml version="1.0" encoding="utf-8"?>
+<p:sld xmlns:a="http://schemas.openxmlformats.org/drawingml/2006/main" xmlns:r="http://schemas.openxmlformats.org/officeDocument/2006/relationships" xmlns:p="http://schemas.openxmlformats.org/presentationml/2006/main">
+  <p:cSld>
+    <p:spTree>
+      <p:nvGrpSpPr>
+        <p:cNvPr id="1" name=""/>
+        <p:cNvGrpSpPr/>
+        <p:nvPr/>
+      </p:nvGrpSpPr>
+      <p:grpSpPr>
+        <a:xfrm>
+          <a:off x="0" y="0"/>
+          <a:ext cx="0" cy="0"/>
+          <a:chOff x="0" y="0"/>
+          <a:chExt cx="0" cy="0"/>
+        </a:xfrm>
+      </p:grpSpPr>
+      <p:sp>
+        <p:nvSpPr>
+          <p:cNvPr id="539649" name="Title 1"/>
+          <p:cNvSpPr>
+            <a:spLocks noGrp="1"/>
+          </p:cNvSpPr>
+          <p:nvPr>
+            <p:ph type="title"/>
+          </p:nvPr>
+        </p:nvSpPr>
+        <p:spPr/>
+        <p:txBody>
+          <a:bodyPr/>
+          <a:lstStyle/>
+          <a:p>
+            <a:r>
+              <a:rPr lang="en-US" dirty="0"/>
+              <a:t>Question 223.4.10  123.22.5</a:t>
+            </a:r>
+          </a:p>
+        </p:txBody>
+      </p:sp>
+      <p:sp>
+        <p:nvSpPr>
+          <p:cNvPr id="539650" name="Content Placeholder 2"/>
+          <p:cNvSpPr>
+            <a:spLocks noGrp="1"/>
+          </p:cNvSpPr>
+          <p:nvPr>
+            <p:ph idx="1"/>
+          </p:nvPr>
+        </p:nvSpPr>
+        <p:spPr/>
+        <p:txBody>
+          <a:bodyPr/>
+          <a:lstStyle/>
+          <a:p>
+            <a:pPr>
+              <a:buFontTx/>
+              <a:buNone/>
+            </a:pPr>
+            <a:r>
+              <a:rPr lang="en-US" dirty="0"/>
+              <a:t>I have 100W of power coming from my speaker. What is the intensity 0.5m from the speaker?</a:t>
+            </a:r>
+          </a:p>
+          <a:p>
+            <a:pPr>
+              <a:buFontTx/>
+              <a:buNone/>
+            </a:pPr>
+            <a:r>
+              <a:rPr lang="en-US" dirty="0"/>
+              <a:t>a) 0.01W</a:t>
+            </a:r>
+          </a:p>
+          <a:p>
+            <a:pPr>
+              <a:buFontTx/>
+              <a:buNone/>
+            </a:pPr>
+            <a:r>
+              <a:rPr lang="en-US" dirty="0"/>
+              <a:t>b) Just under 1W</a:t>
+            </a:r>
+          </a:p>
+          <a:p>
+            <a:pPr>
+              <a:buFontTx/>
+              <a:buNone/>
+            </a:pPr>
+            <a:r>
+              <a:rPr lang="en-US" dirty="0"/>
+              <a:t>c) A little over 10W</a:t>
+            </a:r>
+          </a:p>
+          <a:p>
+            <a:pPr>
+              <a:buFontTx/>
+              <a:buNone/>
+            </a:pPr>
+            <a:r>
+              <a:rPr lang="en-US" dirty="0"/>
+              <a:t>d) A little over 30W</a:t>
+            </a:r>
+          </a:p>
+          <a:p>
+            <a:pPr>
+              <a:buFontTx/>
+              <a:buNone/>
+            </a:pPr>
+            <a:endParaRPr lang="en-US" dirty="0"/>
+          </a:p>
+        </p:txBody>
+      </p:sp>
+    </p:spTree>
+    <p:extLst>
+      <p:ext uri="{BB962C8B-B14F-4D97-AF65-F5344CB8AC3E}">
+        <p14:creationId xmlns:p14="http://schemas.microsoft.com/office/powerpoint/2010/main" val="3337956701"/>
       </p:ext>
     </p:extLst>
   </p:cSld>
@@ -20985,6 +20968,356 @@
   <p:cSld>
     <p:spTree>
       <p:nvGrpSpPr>
+        <p:cNvPr id="1" name="">
+          <a:extLst>
+            <a:ext uri="{FF2B5EF4-FFF2-40B4-BE49-F238E27FC236}">
+              <a16:creationId xmlns:a16="http://schemas.microsoft.com/office/drawing/2014/main" id="{DD88AECC-1563-18CB-52DF-D67311E7FC92}"/>
+            </a:ext>
+          </a:extLst>
+        </p:cNvPr>
+        <p:cNvGrpSpPr/>
+        <p:nvPr/>
+      </p:nvGrpSpPr>
+      <p:grpSpPr>
+        <a:xfrm>
+          <a:off x="0" y="0"/>
+          <a:ext cx="0" cy="0"/>
+          <a:chOff x="0" y="0"/>
+          <a:chExt cx="0" cy="0"/>
+        </a:xfrm>
+      </p:grpSpPr>
+      <p:sp>
+        <p:nvSpPr>
+          <p:cNvPr id="2" name="Title 1">
+            <a:extLst>
+              <a:ext uri="{FF2B5EF4-FFF2-40B4-BE49-F238E27FC236}">
+                <a16:creationId xmlns:a16="http://schemas.microsoft.com/office/drawing/2014/main" id="{93D92E87-9D64-FEF1-F05F-143B84D814BF}"/>
+              </a:ext>
+            </a:extLst>
+          </p:cNvPr>
+          <p:cNvSpPr>
+            <a:spLocks noGrp="1"/>
+          </p:cNvSpPr>
+          <p:nvPr>
+            <p:ph type="title"/>
+          </p:nvPr>
+        </p:nvSpPr>
+        <p:spPr/>
+        <p:txBody>
+          <a:bodyPr/>
+          <a:lstStyle/>
+          <a:p>
+            <a:endParaRPr lang="en-US"/>
+          </a:p>
+        </p:txBody>
+      </p:sp>
+      <p:pic>
+        <p:nvPicPr>
+          <p:cNvPr id="4" name="oC6ZAOiIfKo">
+            <a:extLst>
+              <a:ext uri="{FF2B5EF4-FFF2-40B4-BE49-F238E27FC236}">
+                <a16:creationId xmlns:a16="http://schemas.microsoft.com/office/drawing/2014/main" id="{B78A4F52-3416-5502-A169-10DBE2D1D304}"/>
+              </a:ext>
+            </a:extLst>
+          </p:cNvPr>
+          <p:cNvPicPr>
+            <a:picLocks noGrp="1" noRot="1" noChangeAspect="1"/>
+          </p:cNvPicPr>
+          <p:nvPr>
+            <p:ph idx="1"/>
+            <a:videoFile r:link="rId1"/>
+          </p:nvPr>
+        </p:nvPicPr>
+        <p:blipFill>
+          <a:blip r:embed="rId3"/>
+          <a:stretch>
+            <a:fillRect/>
+          </a:stretch>
+        </p:blipFill>
+        <p:spPr>
+          <a:xfrm>
+            <a:off x="762000" y="1719263"/>
+            <a:ext cx="8001000" cy="4500563"/>
+          </a:xfrm>
+          <a:prstGeom prst="rect">
+            <a:avLst/>
+          </a:prstGeom>
+        </p:spPr>
+      </p:pic>
+    </p:spTree>
+    <p:extLst>
+      <p:ext uri="{BB962C8B-B14F-4D97-AF65-F5344CB8AC3E}">
+        <p14:creationId xmlns:p14="http://schemas.microsoft.com/office/powerpoint/2010/main" val="2085196998"/>
+      </p:ext>
+    </p:extLst>
+  </p:cSld>
+  <p:clrMapOvr>
+    <a:masterClrMapping/>
+  </p:clrMapOvr>
+</p:sld>
+</file>
+
+<file path=ppt/slides/slide4.xml><?xml version="1.0" encoding="utf-8"?>
+<p:sld xmlns:a="http://schemas.openxmlformats.org/drawingml/2006/main" xmlns:r="http://schemas.openxmlformats.org/officeDocument/2006/relationships" xmlns:p="http://schemas.openxmlformats.org/presentationml/2006/main">
+  <p:cSld>
+    <p:spTree>
+      <p:nvGrpSpPr>
+        <p:cNvPr id="1" name=""/>
+        <p:cNvGrpSpPr/>
+        <p:nvPr/>
+      </p:nvGrpSpPr>
+      <p:grpSpPr>
+        <a:xfrm>
+          <a:off x="0" y="0"/>
+          <a:ext cx="0" cy="0"/>
+          <a:chOff x="0" y="0"/>
+          <a:chExt cx="0" cy="0"/>
+        </a:xfrm>
+      </p:grpSpPr>
+      <p:sp>
+        <p:nvSpPr>
+          <p:cNvPr id="2" name="Title 1"/>
+          <p:cNvSpPr>
+            <a:spLocks noGrp="1"/>
+          </p:cNvSpPr>
+          <p:nvPr>
+            <p:ph type="title"/>
+          </p:nvPr>
+        </p:nvSpPr>
+        <p:spPr/>
+        <p:txBody>
+          <a:bodyPr/>
+          <a:lstStyle/>
+          <a:p>
+            <a:r>
+              <a:rPr lang="en-US" dirty="0"/>
+              <a:t>Question  223.4.5     123.22.1</a:t>
+            </a:r>
+          </a:p>
+        </p:txBody>
+      </p:sp>
+      <p:sp>
+        <p:nvSpPr>
+          <p:cNvPr id="3" name="Content Placeholder 2"/>
+          <p:cNvSpPr>
+            <a:spLocks noGrp="1"/>
+          </p:cNvSpPr>
+          <p:nvPr>
+            <p:ph idx="1"/>
+          </p:nvPr>
+        </p:nvSpPr>
+        <p:spPr/>
+        <p:txBody>
+          <a:bodyPr/>
+          <a:lstStyle/>
+          <a:p>
+            <a:pPr>
+              <a:buNone/>
+            </a:pPr>
+            <a:r>
+              <a:rPr lang="en-US" dirty="0"/>
+              <a:t>A 60W light bulb is allowed to burn for 3600s. How much energy has been used?</a:t>
+            </a:r>
+          </a:p>
+          <a:p>
+            <a:pPr marL="514350" indent="-514350">
+              <a:buFont typeface="+mj-lt"/>
+              <a:buAutoNum type="alphaLcParenR"/>
+            </a:pPr>
+            <a:r>
+              <a:rPr lang="en-US" dirty="0"/>
+              <a:t>36000J</a:t>
+            </a:r>
+          </a:p>
+          <a:p>
+            <a:pPr marL="514350" indent="-514350">
+              <a:buFont typeface="+mj-lt"/>
+              <a:buAutoNum type="alphaLcParenR"/>
+            </a:pPr>
+            <a:r>
+              <a:rPr lang="en-US" dirty="0"/>
+              <a:t>72000J</a:t>
+            </a:r>
+          </a:p>
+          <a:p>
+            <a:pPr marL="514350" indent="-514350">
+              <a:buFont typeface="+mj-lt"/>
+              <a:buAutoNum type="alphaLcParenR"/>
+            </a:pPr>
+            <a:r>
+              <a:rPr lang="en-US" dirty="0"/>
+              <a:t>144000J</a:t>
+            </a:r>
+          </a:p>
+          <a:p>
+            <a:pPr marL="514350" indent="-514350">
+              <a:buFont typeface="+mj-lt"/>
+              <a:buAutoNum type="alphaLcParenR"/>
+            </a:pPr>
+            <a:r>
+              <a:rPr lang="en-US" dirty="0"/>
+              <a:t>216000J</a:t>
+            </a:r>
+          </a:p>
+          <a:p>
+            <a:pPr marL="514350" indent="-514350">
+              <a:buFont typeface="+mj-lt"/>
+              <a:buAutoNum type="alphaLcParenR"/>
+            </a:pPr>
+            <a:r>
+              <a:rPr lang="en-US" dirty="0"/>
+              <a:t>5400000J</a:t>
+            </a:r>
+          </a:p>
+          <a:p>
+            <a:pPr>
+              <a:buNone/>
+            </a:pPr>
+            <a:endParaRPr lang="en-US" dirty="0"/>
+          </a:p>
+        </p:txBody>
+      </p:sp>
+      <p:sp>
+        <p:nvSpPr>
+          <p:cNvPr id="4" name="Slide Number Placeholder 3"/>
+          <p:cNvSpPr>
+            <a:spLocks noGrp="1"/>
+          </p:cNvSpPr>
+          <p:nvPr>
+            <p:ph type="sldNum" sz="quarter" idx="12"/>
+          </p:nvPr>
+        </p:nvSpPr>
+        <p:spPr/>
+        <p:txBody>
+          <a:bodyPr/>
+          <a:lstStyle/>
+          <a:p>
+            <a:pPr>
+              <a:defRPr/>
+            </a:pPr>
+            <a:fld id="{64137B81-8888-4253-92EC-0AED2A590749}" type="slidenum">
+              <a:rPr lang="en-US" smtClean="0"/>
+              <a:pPr>
+                <a:defRPr/>
+              </a:pPr>
+              <a:t>4</a:t>
+            </a:fld>
+            <a:endParaRPr lang="en-US"/>
+          </a:p>
+        </p:txBody>
+      </p:sp>
+    </p:spTree>
+    <p:extLst>
+      <p:ext uri="{BB962C8B-B14F-4D97-AF65-F5344CB8AC3E}">
+        <p14:creationId xmlns:p14="http://schemas.microsoft.com/office/powerpoint/2010/main" val="1716686287"/>
+      </p:ext>
+    </p:extLst>
+  </p:cSld>
+  <p:clrMapOvr>
+    <a:masterClrMapping/>
+  </p:clrMapOvr>
+</p:sld>
+</file>
+
+<file path=ppt/slides/slide40.xml><?xml version="1.0" encoding="utf-8"?>
+<p:sld xmlns:a="http://schemas.openxmlformats.org/drawingml/2006/main" xmlns:r="http://schemas.openxmlformats.org/officeDocument/2006/relationships" xmlns:p="http://schemas.openxmlformats.org/presentationml/2006/main">
+  <p:cSld>
+    <p:spTree>
+      <p:nvGrpSpPr>
+        <p:cNvPr id="1" name="">
+          <a:extLst>
+            <a:ext uri="{FF2B5EF4-FFF2-40B4-BE49-F238E27FC236}">
+              <a16:creationId xmlns:a16="http://schemas.microsoft.com/office/drawing/2014/main" id="{3EEBEF48-DDB6-B109-9250-E6B55295ADFD}"/>
+            </a:ext>
+          </a:extLst>
+        </p:cNvPr>
+        <p:cNvGrpSpPr/>
+        <p:nvPr/>
+      </p:nvGrpSpPr>
+      <p:grpSpPr>
+        <a:xfrm>
+          <a:off x="0" y="0"/>
+          <a:ext cx="0" cy="0"/>
+          <a:chOff x="0" y="0"/>
+          <a:chExt cx="0" cy="0"/>
+        </a:xfrm>
+      </p:grpSpPr>
+      <p:sp>
+        <p:nvSpPr>
+          <p:cNvPr id="2" name="Title 1">
+            <a:extLst>
+              <a:ext uri="{FF2B5EF4-FFF2-40B4-BE49-F238E27FC236}">
+                <a16:creationId xmlns:a16="http://schemas.microsoft.com/office/drawing/2014/main" id="{F85BF613-F866-5543-8B68-2B3E438EFA11}"/>
+              </a:ext>
+            </a:extLst>
+          </p:cNvPr>
+          <p:cNvSpPr>
+            <a:spLocks noGrp="1"/>
+          </p:cNvSpPr>
+          <p:nvPr>
+            <p:ph type="title"/>
+          </p:nvPr>
+        </p:nvSpPr>
+        <p:spPr/>
+        <p:txBody>
+          <a:bodyPr/>
+          <a:lstStyle/>
+          <a:p>
+            <a:endParaRPr lang="en-US"/>
+          </a:p>
+        </p:txBody>
+      </p:sp>
+      <p:pic>
+        <p:nvPicPr>
+          <p:cNvPr id="4" name="xoKNyUpnn20">
+            <a:extLst>
+              <a:ext uri="{FF2B5EF4-FFF2-40B4-BE49-F238E27FC236}">
+                <a16:creationId xmlns:a16="http://schemas.microsoft.com/office/drawing/2014/main" id="{37523D85-4506-B491-2381-51F7EB3E055E}"/>
+              </a:ext>
+            </a:extLst>
+          </p:cNvPr>
+          <p:cNvPicPr>
+            <a:picLocks noGrp="1" noRot="1" noChangeAspect="1"/>
+          </p:cNvPicPr>
+          <p:nvPr>
+            <p:ph idx="1"/>
+            <a:videoFile r:link="rId1"/>
+          </p:nvPr>
+        </p:nvPicPr>
+        <p:blipFill>
+          <a:blip r:embed="rId3"/>
+          <a:stretch>
+            <a:fillRect/>
+          </a:stretch>
+        </p:blipFill>
+        <p:spPr>
+          <a:xfrm>
+            <a:off x="76200" y="1333500"/>
+            <a:ext cx="9067800" cy="5100638"/>
+          </a:xfrm>
+          <a:prstGeom prst="rect">
+            <a:avLst/>
+          </a:prstGeom>
+        </p:spPr>
+      </p:pic>
+    </p:spTree>
+    <p:extLst>
+      <p:ext uri="{BB962C8B-B14F-4D97-AF65-F5344CB8AC3E}">
+        <p14:creationId xmlns:p14="http://schemas.microsoft.com/office/powerpoint/2010/main" val="3064395866"/>
+      </p:ext>
+    </p:extLst>
+  </p:cSld>
+  <p:clrMapOvr>
+    <a:masterClrMapping/>
+  </p:clrMapOvr>
+</p:sld>
+</file>
+
+<file path=ppt/slides/slide41.xml><?xml version="1.0" encoding="utf-8"?>
+<p:sld xmlns:a="http://schemas.openxmlformats.org/drawingml/2006/main" xmlns:r="http://schemas.openxmlformats.org/officeDocument/2006/relationships" xmlns:p="http://schemas.openxmlformats.org/presentationml/2006/main">
+  <p:cSld>
+    <p:spTree>
+      <p:nvGrpSpPr>
         <p:cNvPr id="1" name=""/>
         <p:cNvGrpSpPr/>
         <p:nvPr/>
@@ -21215,169 +21548,7 @@
 </p:sld>
 </file>
 
-<file path=ppt/slides/slide4.xml><?xml version="1.0" encoding="utf-8"?>
-<p:sld xmlns:a="http://schemas.openxmlformats.org/drawingml/2006/main" xmlns:r="http://schemas.openxmlformats.org/officeDocument/2006/relationships" xmlns:p="http://schemas.openxmlformats.org/presentationml/2006/main">
-  <p:cSld>
-    <p:spTree>
-      <p:nvGrpSpPr>
-        <p:cNvPr id="1" name=""/>
-        <p:cNvGrpSpPr/>
-        <p:nvPr/>
-      </p:nvGrpSpPr>
-      <p:grpSpPr>
-        <a:xfrm>
-          <a:off x="0" y="0"/>
-          <a:ext cx="0" cy="0"/>
-          <a:chOff x="0" y="0"/>
-          <a:chExt cx="0" cy="0"/>
-        </a:xfrm>
-      </p:grpSpPr>
-      <p:sp>
-        <p:nvSpPr>
-          <p:cNvPr id="2" name="Title 1"/>
-          <p:cNvSpPr>
-            <a:spLocks noGrp="1"/>
-          </p:cNvSpPr>
-          <p:nvPr>
-            <p:ph type="title"/>
-          </p:nvPr>
-        </p:nvSpPr>
-        <p:spPr/>
-        <p:txBody>
-          <a:bodyPr/>
-          <a:lstStyle/>
-          <a:p>
-            <a:r>
-              <a:rPr lang="en-US" dirty="0"/>
-              <a:t>Question  223.4.5     123.22.1</a:t>
-            </a:r>
-          </a:p>
-        </p:txBody>
-      </p:sp>
-      <p:sp>
-        <p:nvSpPr>
-          <p:cNvPr id="3" name="Content Placeholder 2"/>
-          <p:cNvSpPr>
-            <a:spLocks noGrp="1"/>
-          </p:cNvSpPr>
-          <p:nvPr>
-            <p:ph idx="1"/>
-          </p:nvPr>
-        </p:nvSpPr>
-        <p:spPr/>
-        <p:txBody>
-          <a:bodyPr/>
-          <a:lstStyle/>
-          <a:p>
-            <a:pPr>
-              <a:buNone/>
-            </a:pPr>
-            <a:r>
-              <a:rPr lang="en-US" dirty="0"/>
-              <a:t>A 60W light bulb is allowed to burn for 3600s. How much energy has been used?</a:t>
-            </a:r>
-          </a:p>
-          <a:p>
-            <a:pPr marL="514350" indent="-514350">
-              <a:buFont typeface="+mj-lt"/>
-              <a:buAutoNum type="alphaLcParenR"/>
-            </a:pPr>
-            <a:r>
-              <a:rPr lang="en-US" dirty="0"/>
-              <a:t>36000J</a:t>
-            </a:r>
-          </a:p>
-          <a:p>
-            <a:pPr marL="514350" indent="-514350">
-              <a:buFont typeface="+mj-lt"/>
-              <a:buAutoNum type="alphaLcParenR"/>
-            </a:pPr>
-            <a:r>
-              <a:rPr lang="en-US" dirty="0"/>
-              <a:t>72000J</a:t>
-            </a:r>
-          </a:p>
-          <a:p>
-            <a:pPr marL="514350" indent="-514350">
-              <a:buFont typeface="+mj-lt"/>
-              <a:buAutoNum type="alphaLcParenR"/>
-            </a:pPr>
-            <a:r>
-              <a:rPr lang="en-US" dirty="0"/>
-              <a:t>144000J</a:t>
-            </a:r>
-          </a:p>
-          <a:p>
-            <a:pPr marL="514350" indent="-514350">
-              <a:buFont typeface="+mj-lt"/>
-              <a:buAutoNum type="alphaLcParenR"/>
-            </a:pPr>
-            <a:r>
-              <a:rPr lang="en-US" dirty="0"/>
-              <a:t>216000J</a:t>
-            </a:r>
-          </a:p>
-          <a:p>
-            <a:pPr marL="514350" indent="-514350">
-              <a:buFont typeface="+mj-lt"/>
-              <a:buAutoNum type="alphaLcParenR"/>
-            </a:pPr>
-            <a:r>
-              <a:rPr lang="en-US" dirty="0"/>
-              <a:t>5400000J</a:t>
-            </a:r>
-          </a:p>
-          <a:p>
-            <a:pPr>
-              <a:buNone/>
-            </a:pPr>
-            <a:endParaRPr lang="en-US" dirty="0"/>
-          </a:p>
-        </p:txBody>
-      </p:sp>
-      <p:sp>
-        <p:nvSpPr>
-          <p:cNvPr id="4" name="Slide Number Placeholder 3"/>
-          <p:cNvSpPr>
-            <a:spLocks noGrp="1"/>
-          </p:cNvSpPr>
-          <p:nvPr>
-            <p:ph type="sldNum" sz="quarter" idx="12"/>
-          </p:nvPr>
-        </p:nvSpPr>
-        <p:spPr/>
-        <p:txBody>
-          <a:bodyPr/>
-          <a:lstStyle/>
-          <a:p>
-            <a:pPr>
-              <a:defRPr/>
-            </a:pPr>
-            <a:fld id="{64137B81-8888-4253-92EC-0AED2A590749}" type="slidenum">
-              <a:rPr lang="en-US" smtClean="0"/>
-              <a:pPr>
-                <a:defRPr/>
-              </a:pPr>
-              <a:t>4</a:t>
-            </a:fld>
-            <a:endParaRPr lang="en-US"/>
-          </a:p>
-        </p:txBody>
-      </p:sp>
-    </p:spTree>
-    <p:extLst>
-      <p:ext uri="{BB962C8B-B14F-4D97-AF65-F5344CB8AC3E}">
-        <p14:creationId xmlns:p14="http://schemas.microsoft.com/office/powerpoint/2010/main" val="1716686287"/>
-      </p:ext>
-    </p:extLst>
-  </p:cSld>
-  <p:clrMapOvr>
-    <a:masterClrMapping/>
-  </p:clrMapOvr>
-</p:sld>
-</file>
-
-<file path=ppt/slides/slide40.xml><?xml version="1.0" encoding="utf-8"?>
+<file path=ppt/slides/slide42.xml><?xml version="1.0" encoding="utf-8"?>
 <p:sld xmlns:a="http://schemas.openxmlformats.org/drawingml/2006/main" xmlns:r="http://schemas.openxmlformats.org/officeDocument/2006/relationships" xmlns:p="http://schemas.openxmlformats.org/presentationml/2006/main">
   <p:cSld>
     <p:spTree>
@@ -21439,7 +21610,7 @@
 </p:sld>
 </file>
 
-<file path=ppt/slides/slide41.xml><?xml version="1.0" encoding="utf-8"?>
+<file path=ppt/slides/slide43.xml><?xml version="1.0" encoding="utf-8"?>
 <p:sld xmlns:a="http://schemas.openxmlformats.org/drawingml/2006/main" xmlns:r="http://schemas.openxmlformats.org/officeDocument/2006/relationships" xmlns:p="http://schemas.openxmlformats.org/presentationml/2006/main">
   <p:cSld>
     <p:spTree>
@@ -21495,7 +21666,7 @@
 </p:sld>
 </file>
 
-<file path=ppt/slides/slide42.xml><?xml version="1.0" encoding="utf-8"?>
+<file path=ppt/slides/slide44.xml><?xml version="1.0" encoding="utf-8"?>
 <p:sld xmlns:a="http://schemas.openxmlformats.org/drawingml/2006/main" xmlns:r="http://schemas.openxmlformats.org/officeDocument/2006/relationships" xmlns:p="http://schemas.openxmlformats.org/presentationml/2006/main">
   <p:cSld>
     <p:spTree>
@@ -21551,7 +21722,7 @@
 </p:sld>
 </file>
 
-<file path=ppt/slides/slide43.xml><?xml version="1.0" encoding="utf-8"?>
+<file path=ppt/slides/slide45.xml><?xml version="1.0" encoding="utf-8"?>
 <p:sld xmlns:a="http://schemas.openxmlformats.org/drawingml/2006/main" xmlns:r="http://schemas.openxmlformats.org/officeDocument/2006/relationships" xmlns:p="http://schemas.openxmlformats.org/presentationml/2006/main">
   <p:cSld>
     <p:spTree>
@@ -21696,7 +21867,7 @@
             <a:fld id="{85539879-F00E-4549-815A-3F0634DD4490}" type="slidenum">
               <a:rPr lang="en-US" smtClean="0"/>
               <a:pPr/>
-              <a:t>43</a:t>
+              <a:t>45</a:t>
             </a:fld>
             <a:endParaRPr lang="en-US"/>
           </a:p>
@@ -21715,7 +21886,7 @@
 </p:sld>
 </file>
 
-<file path=ppt/slides/slide44.xml><?xml version="1.0" encoding="utf-8"?>
+<file path=ppt/slides/slide46.xml><?xml version="1.0" encoding="utf-8"?>
 <p:sld xmlns:a="http://schemas.openxmlformats.org/drawingml/2006/main" xmlns:r="http://schemas.openxmlformats.org/officeDocument/2006/relationships" xmlns:p="http://schemas.openxmlformats.org/presentationml/2006/main">
   <p:cSld>
     <p:spTree>
@@ -21876,7 +22047,7 @@
 </p:sld>
 </file>
 
-<file path=ppt/slides/slide45.xml><?xml version="1.0" encoding="utf-8"?>
+<file path=ppt/slides/slide47.xml><?xml version="1.0" encoding="utf-8"?>
 <p:sld xmlns:a="http://schemas.openxmlformats.org/drawingml/2006/main" xmlns:r="http://schemas.openxmlformats.org/officeDocument/2006/relationships" xmlns:p="http://schemas.openxmlformats.org/presentationml/2006/main">
   <p:cSld>
     <p:spTree>
@@ -22065,7 +22236,7 @@
 </p:sld>
 </file>
 
-<file path=ppt/slides/slide46.xml><?xml version="1.0" encoding="utf-8"?>
+<file path=ppt/slides/slide48.xml><?xml version="1.0" encoding="utf-8"?>
 <p:sld xmlns:a="http://schemas.openxmlformats.org/drawingml/2006/main" xmlns:r="http://schemas.openxmlformats.org/officeDocument/2006/relationships" xmlns:p="http://schemas.openxmlformats.org/presentationml/2006/main">
   <p:cSld>
     <p:spTree>
@@ -22254,272 +22425,6 @@
 </p:sld>
 </file>
 
-<file path=ppt/slides/slide47.xml><?xml version="1.0" encoding="utf-8"?>
-<p:sld xmlns:a="http://schemas.openxmlformats.org/drawingml/2006/main" xmlns:r="http://schemas.openxmlformats.org/officeDocument/2006/relationships" xmlns:p="http://schemas.openxmlformats.org/presentationml/2006/main">
-  <p:cSld>
-    <p:spTree>
-      <p:nvGrpSpPr>
-        <p:cNvPr id="1" name=""/>
-        <p:cNvGrpSpPr/>
-        <p:nvPr/>
-      </p:nvGrpSpPr>
-      <p:grpSpPr>
-        <a:xfrm>
-          <a:off x="0" y="0"/>
-          <a:ext cx="0" cy="0"/>
-          <a:chOff x="0" y="0"/>
-          <a:chExt cx="0" cy="0"/>
-        </a:xfrm>
-      </p:grpSpPr>
-      <p:sp>
-        <p:nvSpPr>
-          <p:cNvPr id="2" name="Title 1"/>
-          <p:cNvSpPr>
-            <a:spLocks noGrp="1"/>
-          </p:cNvSpPr>
-          <p:nvPr>
-            <p:ph type="title"/>
-          </p:nvPr>
-        </p:nvSpPr>
-        <p:spPr/>
-        <p:txBody>
-          <a:bodyPr/>
-          <a:lstStyle/>
-          <a:p>
-            <a:r>
-              <a:rPr lang="en-US" dirty="0"/>
-              <a:t>Question 223.6.0.1</a:t>
-            </a:r>
-          </a:p>
-        </p:txBody>
-      </p:sp>
-      <p:sp>
-        <p:nvSpPr>
-          <p:cNvPr id="3" name="Content Placeholder 2"/>
-          <p:cNvSpPr>
-            <a:spLocks noGrp="1"/>
-          </p:cNvSpPr>
-          <p:nvPr>
-            <p:ph idx="1"/>
-          </p:nvPr>
-        </p:nvSpPr>
-        <p:spPr/>
-        <p:txBody>
-          <a:bodyPr/>
-          <a:lstStyle/>
-          <a:p>
-            <a:pPr marL="0" indent="0">
-              <a:buNone/>
-            </a:pPr>
-            <a:r>
-              <a:rPr lang="en-US" dirty="0"/>
-              <a:t>I have two sinusoidal waves in the same medium. The waves travel the same direction (unlike our class demonstration).  If the resultant wave has a larger amplitude than the original waves we call this…</a:t>
-            </a:r>
-          </a:p>
-          <a:p>
-            <a:pPr marL="514350" indent="-514350">
-              <a:buAutoNum type="alphaLcParenR"/>
-            </a:pPr>
-            <a:r>
-              <a:rPr lang="en-US" dirty="0"/>
-              <a:t>Constructive interference</a:t>
-            </a:r>
-          </a:p>
-          <a:p>
-            <a:pPr marL="514350" indent="-514350">
-              <a:buAutoNum type="alphaLcParenR"/>
-            </a:pPr>
-            <a:r>
-              <a:rPr lang="en-US" dirty="0"/>
-              <a:t>Destructive interference</a:t>
-            </a:r>
-          </a:p>
-          <a:p>
-            <a:pPr marL="514350" indent="-514350">
-              <a:buAutoNum type="alphaLcParenR"/>
-            </a:pPr>
-            <a:r>
-              <a:rPr lang="en-US" dirty="0"/>
-              <a:t>A miracle</a:t>
-            </a:r>
-          </a:p>
-        </p:txBody>
-      </p:sp>
-      <p:sp>
-        <p:nvSpPr>
-          <p:cNvPr id="4" name="Slide Number Placeholder 3"/>
-          <p:cNvSpPr>
-            <a:spLocks noGrp="1"/>
-          </p:cNvSpPr>
-          <p:nvPr>
-            <p:ph type="sldNum" sz="quarter" idx="12"/>
-          </p:nvPr>
-        </p:nvSpPr>
-        <p:spPr/>
-        <p:txBody>
-          <a:bodyPr/>
-          <a:lstStyle/>
-          <a:p>
-            <a:pPr>
-              <a:defRPr/>
-            </a:pPr>
-            <a:fld id="{64137B81-8888-4253-92EC-0AED2A590749}" type="slidenum">
-              <a:rPr lang="en-US" smtClean="0"/>
-              <a:pPr>
-                <a:defRPr/>
-              </a:pPr>
-              <a:t>47</a:t>
-            </a:fld>
-            <a:endParaRPr lang="en-US"/>
-          </a:p>
-        </p:txBody>
-      </p:sp>
-    </p:spTree>
-    <p:extLst>
-      <p:ext uri="{BB962C8B-B14F-4D97-AF65-F5344CB8AC3E}">
-        <p14:creationId xmlns:p14="http://schemas.microsoft.com/office/powerpoint/2010/main" val="1497180699"/>
-      </p:ext>
-    </p:extLst>
-  </p:cSld>
-  <p:clrMapOvr>
-    <a:masterClrMapping/>
-  </p:clrMapOvr>
-</p:sld>
-</file>
-
-<file path=ppt/slides/slide48.xml><?xml version="1.0" encoding="utf-8"?>
-<p:sld xmlns:a="http://schemas.openxmlformats.org/drawingml/2006/main" xmlns:r="http://schemas.openxmlformats.org/officeDocument/2006/relationships" xmlns:p="http://schemas.openxmlformats.org/presentationml/2006/main">
-  <p:cSld>
-    <p:spTree>
-      <p:nvGrpSpPr>
-        <p:cNvPr id="1" name=""/>
-        <p:cNvGrpSpPr/>
-        <p:nvPr/>
-      </p:nvGrpSpPr>
-      <p:grpSpPr>
-        <a:xfrm>
-          <a:off x="0" y="0"/>
-          <a:ext cx="0" cy="0"/>
-          <a:chOff x="0" y="0"/>
-          <a:chExt cx="0" cy="0"/>
-        </a:xfrm>
-      </p:grpSpPr>
-      <p:sp>
-        <p:nvSpPr>
-          <p:cNvPr id="2" name="Title 1"/>
-          <p:cNvSpPr>
-            <a:spLocks noGrp="1"/>
-          </p:cNvSpPr>
-          <p:nvPr>
-            <p:ph type="title"/>
-          </p:nvPr>
-        </p:nvSpPr>
-        <p:spPr/>
-        <p:txBody>
-          <a:bodyPr/>
-          <a:lstStyle/>
-          <a:p>
-            <a:r>
-              <a:rPr lang="en-US" dirty="0"/>
-              <a:t>Question 223.6.0.2</a:t>
-            </a:r>
-          </a:p>
-        </p:txBody>
-      </p:sp>
-      <p:sp>
-        <p:nvSpPr>
-          <p:cNvPr id="3" name="Content Placeholder 2"/>
-          <p:cNvSpPr>
-            <a:spLocks noGrp="1"/>
-          </p:cNvSpPr>
-          <p:nvPr>
-            <p:ph idx="1"/>
-          </p:nvPr>
-        </p:nvSpPr>
-        <p:spPr/>
-        <p:txBody>
-          <a:bodyPr/>
-          <a:lstStyle/>
-          <a:p>
-            <a:pPr marL="0" indent="0">
-              <a:buNone/>
-            </a:pPr>
-            <a:r>
-              <a:rPr lang="en-US" dirty="0"/>
-              <a:t>I have two sinusoidal waves in the same medium. The waves travel the same direction (unlike our class demonstration).  If the resultant wave has a smaller amplitude than the original waves we call this…</a:t>
-            </a:r>
-          </a:p>
-          <a:p>
-            <a:pPr marL="514350" indent="-514350">
-              <a:buAutoNum type="alphaLcParenR"/>
-            </a:pPr>
-            <a:r>
-              <a:rPr lang="en-US" dirty="0"/>
-              <a:t>Constructive interference</a:t>
-            </a:r>
-          </a:p>
-          <a:p>
-            <a:pPr marL="514350" indent="-514350">
-              <a:buAutoNum type="alphaLcParenR"/>
-            </a:pPr>
-            <a:r>
-              <a:rPr lang="en-US" dirty="0"/>
-              <a:t>Destructive interference</a:t>
-            </a:r>
-          </a:p>
-          <a:p>
-            <a:pPr marL="514350" indent="-514350">
-              <a:buAutoNum type="alphaLcParenR"/>
-            </a:pPr>
-            <a:r>
-              <a:rPr lang="en-US" dirty="0"/>
-              <a:t>Depressing</a:t>
-            </a:r>
-          </a:p>
-        </p:txBody>
-      </p:sp>
-      <p:sp>
-        <p:nvSpPr>
-          <p:cNvPr id="4" name="Slide Number Placeholder 3"/>
-          <p:cNvSpPr>
-            <a:spLocks noGrp="1"/>
-          </p:cNvSpPr>
-          <p:nvPr>
-            <p:ph type="sldNum" sz="quarter" idx="12"/>
-          </p:nvPr>
-        </p:nvSpPr>
-        <p:spPr/>
-        <p:txBody>
-          <a:bodyPr/>
-          <a:lstStyle/>
-          <a:p>
-            <a:pPr>
-              <a:defRPr/>
-            </a:pPr>
-            <a:fld id="{64137B81-8888-4253-92EC-0AED2A590749}" type="slidenum">
-              <a:rPr lang="en-US" smtClean="0"/>
-              <a:pPr>
-                <a:defRPr/>
-              </a:pPr>
-              <a:t>48</a:t>
-            </a:fld>
-            <a:endParaRPr lang="en-US"/>
-          </a:p>
-        </p:txBody>
-      </p:sp>
-    </p:spTree>
-    <p:extLst>
-      <p:ext uri="{BB962C8B-B14F-4D97-AF65-F5344CB8AC3E}">
-        <p14:creationId xmlns:p14="http://schemas.microsoft.com/office/powerpoint/2010/main" val="4119617871"/>
-      </p:ext>
-    </p:extLst>
-  </p:cSld>
-  <p:clrMapOvr>
-    <a:masterClrMapping/>
-  </p:clrMapOvr>
-</p:sld>
-</file>
-
 <file path=ppt/slides/slide49.xml><?xml version="1.0" encoding="utf-8"?>
 <p:sld xmlns:a="http://schemas.openxmlformats.org/drawingml/2006/main" xmlns:r="http://schemas.openxmlformats.org/officeDocument/2006/relationships" xmlns:p="http://schemas.openxmlformats.org/presentationml/2006/main">
   <p:cSld>
@@ -22554,7 +22459,7 @@
           <a:p>
             <a:r>
               <a:rPr lang="en-US" dirty="0"/>
-              <a:t>Question 223.6.0.3</a:t>
+              <a:t>Question 223.6.0.1</a:t>
             </a:r>
           </a:p>
         </p:txBody>
@@ -22571,9 +22476,7 @@
         </p:nvSpPr>
         <p:spPr/>
         <p:txBody>
-          <a:bodyPr>
-            <a:normAutofit lnSpcReduction="10000"/>
-          </a:bodyPr>
+          <a:bodyPr/>
           <a:lstStyle/>
           <a:p>
             <a:pPr marL="0" indent="0">
@@ -22581,7 +22484,7 @@
             </a:pPr>
             <a:r>
               <a:rPr lang="en-US" dirty="0"/>
-              <a:t>I have two sinusoidal waves in the same medium. The waves travel the same direction (unlike our class demonstration).  Sometimes we get constructive and sometimes destructive interference. What makes the difference?</a:t>
+              <a:t>I have two sinusoidal waves in the same medium. The waves travel the same direction (unlike our class demonstration).  If the resultant wave has a larger amplitude than the original waves we call this…</a:t>
             </a:r>
           </a:p>
           <a:p>
@@ -22590,7 +22493,7 @@
             </a:pPr>
             <a:r>
               <a:rPr lang="en-US" dirty="0"/>
-              <a:t>The relative amplitude of the waves</a:t>
+              <a:t>Constructive interference</a:t>
             </a:r>
           </a:p>
           <a:p>
@@ -22599,7 +22502,7 @@
             </a:pPr>
             <a:r>
               <a:rPr lang="en-US" dirty="0"/>
-              <a:t>The relative phase constant of the waves</a:t>
+              <a:t>Destructive interference</a:t>
             </a:r>
           </a:p>
           <a:p>
@@ -22608,16 +22511,7 @@
             </a:pPr>
             <a:r>
               <a:rPr lang="en-US" dirty="0"/>
-              <a:t>The wavelength of the waves</a:t>
-            </a:r>
-          </a:p>
-          <a:p>
-            <a:pPr marL="514350" indent="-514350">
-              <a:buAutoNum type="alphaLcParenR"/>
-            </a:pPr>
-            <a:r>
-              <a:rPr lang="en-US" dirty="0"/>
-              <a:t>Random processes</a:t>
+              <a:t>A miracle</a:t>
             </a:r>
           </a:p>
         </p:txBody>
@@ -22654,7 +22548,7 @@
     </p:spTree>
     <p:extLst>
       <p:ext uri="{BB962C8B-B14F-4D97-AF65-F5344CB8AC3E}">
-        <p14:creationId xmlns:p14="http://schemas.microsoft.com/office/powerpoint/2010/main" val="778798007"/>
+        <p14:creationId xmlns:p14="http://schemas.microsoft.com/office/powerpoint/2010/main" val="1497180699"/>
       </p:ext>
     </p:extLst>
   </p:cSld>
@@ -22796,6 +22690,283 @@
 </file>
 
 <file path=ppt/slides/slide50.xml><?xml version="1.0" encoding="utf-8"?>
+<p:sld xmlns:a="http://schemas.openxmlformats.org/drawingml/2006/main" xmlns:r="http://schemas.openxmlformats.org/officeDocument/2006/relationships" xmlns:p="http://schemas.openxmlformats.org/presentationml/2006/main">
+  <p:cSld>
+    <p:spTree>
+      <p:nvGrpSpPr>
+        <p:cNvPr id="1" name=""/>
+        <p:cNvGrpSpPr/>
+        <p:nvPr/>
+      </p:nvGrpSpPr>
+      <p:grpSpPr>
+        <a:xfrm>
+          <a:off x="0" y="0"/>
+          <a:ext cx="0" cy="0"/>
+          <a:chOff x="0" y="0"/>
+          <a:chExt cx="0" cy="0"/>
+        </a:xfrm>
+      </p:grpSpPr>
+      <p:sp>
+        <p:nvSpPr>
+          <p:cNvPr id="2" name="Title 1"/>
+          <p:cNvSpPr>
+            <a:spLocks noGrp="1"/>
+          </p:cNvSpPr>
+          <p:nvPr>
+            <p:ph type="title"/>
+          </p:nvPr>
+        </p:nvSpPr>
+        <p:spPr/>
+        <p:txBody>
+          <a:bodyPr/>
+          <a:lstStyle/>
+          <a:p>
+            <a:r>
+              <a:rPr lang="en-US" dirty="0"/>
+              <a:t>Question 223.6.0.2</a:t>
+            </a:r>
+          </a:p>
+        </p:txBody>
+      </p:sp>
+      <p:sp>
+        <p:nvSpPr>
+          <p:cNvPr id="3" name="Content Placeholder 2"/>
+          <p:cNvSpPr>
+            <a:spLocks noGrp="1"/>
+          </p:cNvSpPr>
+          <p:nvPr>
+            <p:ph idx="1"/>
+          </p:nvPr>
+        </p:nvSpPr>
+        <p:spPr/>
+        <p:txBody>
+          <a:bodyPr/>
+          <a:lstStyle/>
+          <a:p>
+            <a:pPr marL="0" indent="0">
+              <a:buNone/>
+            </a:pPr>
+            <a:r>
+              <a:rPr lang="en-US" dirty="0"/>
+              <a:t>I have two sinusoidal waves in the same medium. The waves travel the same direction (unlike our class demonstration).  If the resultant wave has a smaller amplitude than the original waves we call this…</a:t>
+            </a:r>
+          </a:p>
+          <a:p>
+            <a:pPr marL="514350" indent="-514350">
+              <a:buAutoNum type="alphaLcParenR"/>
+            </a:pPr>
+            <a:r>
+              <a:rPr lang="en-US" dirty="0"/>
+              <a:t>Constructive interference</a:t>
+            </a:r>
+          </a:p>
+          <a:p>
+            <a:pPr marL="514350" indent="-514350">
+              <a:buAutoNum type="alphaLcParenR"/>
+            </a:pPr>
+            <a:r>
+              <a:rPr lang="en-US" dirty="0"/>
+              <a:t>Destructive interference</a:t>
+            </a:r>
+          </a:p>
+          <a:p>
+            <a:pPr marL="514350" indent="-514350">
+              <a:buAutoNum type="alphaLcParenR"/>
+            </a:pPr>
+            <a:r>
+              <a:rPr lang="en-US" dirty="0"/>
+              <a:t>Depressing</a:t>
+            </a:r>
+          </a:p>
+        </p:txBody>
+      </p:sp>
+      <p:sp>
+        <p:nvSpPr>
+          <p:cNvPr id="4" name="Slide Number Placeholder 3"/>
+          <p:cNvSpPr>
+            <a:spLocks noGrp="1"/>
+          </p:cNvSpPr>
+          <p:nvPr>
+            <p:ph type="sldNum" sz="quarter" idx="12"/>
+          </p:nvPr>
+        </p:nvSpPr>
+        <p:spPr/>
+        <p:txBody>
+          <a:bodyPr/>
+          <a:lstStyle/>
+          <a:p>
+            <a:pPr>
+              <a:defRPr/>
+            </a:pPr>
+            <a:fld id="{64137B81-8888-4253-92EC-0AED2A590749}" type="slidenum">
+              <a:rPr lang="en-US" smtClean="0"/>
+              <a:pPr>
+                <a:defRPr/>
+              </a:pPr>
+              <a:t>50</a:t>
+            </a:fld>
+            <a:endParaRPr lang="en-US"/>
+          </a:p>
+        </p:txBody>
+      </p:sp>
+    </p:spTree>
+    <p:extLst>
+      <p:ext uri="{BB962C8B-B14F-4D97-AF65-F5344CB8AC3E}">
+        <p14:creationId xmlns:p14="http://schemas.microsoft.com/office/powerpoint/2010/main" val="4119617871"/>
+      </p:ext>
+    </p:extLst>
+  </p:cSld>
+  <p:clrMapOvr>
+    <a:masterClrMapping/>
+  </p:clrMapOvr>
+</p:sld>
+</file>
+
+<file path=ppt/slides/slide51.xml><?xml version="1.0" encoding="utf-8"?>
+<p:sld xmlns:a="http://schemas.openxmlformats.org/drawingml/2006/main" xmlns:r="http://schemas.openxmlformats.org/officeDocument/2006/relationships" xmlns:p="http://schemas.openxmlformats.org/presentationml/2006/main">
+  <p:cSld>
+    <p:spTree>
+      <p:nvGrpSpPr>
+        <p:cNvPr id="1" name=""/>
+        <p:cNvGrpSpPr/>
+        <p:nvPr/>
+      </p:nvGrpSpPr>
+      <p:grpSpPr>
+        <a:xfrm>
+          <a:off x="0" y="0"/>
+          <a:ext cx="0" cy="0"/>
+          <a:chOff x="0" y="0"/>
+          <a:chExt cx="0" cy="0"/>
+        </a:xfrm>
+      </p:grpSpPr>
+      <p:sp>
+        <p:nvSpPr>
+          <p:cNvPr id="2" name="Title 1"/>
+          <p:cNvSpPr>
+            <a:spLocks noGrp="1"/>
+          </p:cNvSpPr>
+          <p:nvPr>
+            <p:ph type="title"/>
+          </p:nvPr>
+        </p:nvSpPr>
+        <p:spPr/>
+        <p:txBody>
+          <a:bodyPr/>
+          <a:lstStyle/>
+          <a:p>
+            <a:r>
+              <a:rPr lang="en-US" dirty="0"/>
+              <a:t>Question 223.6.0.3</a:t>
+            </a:r>
+          </a:p>
+        </p:txBody>
+      </p:sp>
+      <p:sp>
+        <p:nvSpPr>
+          <p:cNvPr id="3" name="Content Placeholder 2"/>
+          <p:cNvSpPr>
+            <a:spLocks noGrp="1"/>
+          </p:cNvSpPr>
+          <p:nvPr>
+            <p:ph idx="1"/>
+          </p:nvPr>
+        </p:nvSpPr>
+        <p:spPr/>
+        <p:txBody>
+          <a:bodyPr>
+            <a:normAutofit lnSpcReduction="10000"/>
+          </a:bodyPr>
+          <a:lstStyle/>
+          <a:p>
+            <a:pPr marL="0" indent="0">
+              <a:buNone/>
+            </a:pPr>
+            <a:r>
+              <a:rPr lang="en-US" dirty="0"/>
+              <a:t>I have two sinusoidal waves in the same medium. The waves travel the same direction (unlike our class demonstration).  Sometimes we get constructive and sometimes destructive interference. What makes the difference?</a:t>
+            </a:r>
+          </a:p>
+          <a:p>
+            <a:pPr marL="514350" indent="-514350">
+              <a:buAutoNum type="alphaLcParenR"/>
+            </a:pPr>
+            <a:r>
+              <a:rPr lang="en-US" dirty="0"/>
+              <a:t>The relative amplitude of the waves</a:t>
+            </a:r>
+          </a:p>
+          <a:p>
+            <a:pPr marL="514350" indent="-514350">
+              <a:buAutoNum type="alphaLcParenR"/>
+            </a:pPr>
+            <a:r>
+              <a:rPr lang="en-US" dirty="0"/>
+              <a:t>The relative phase constant of the waves</a:t>
+            </a:r>
+          </a:p>
+          <a:p>
+            <a:pPr marL="514350" indent="-514350">
+              <a:buAutoNum type="alphaLcParenR"/>
+            </a:pPr>
+            <a:r>
+              <a:rPr lang="en-US" dirty="0"/>
+              <a:t>The wavelength of the waves</a:t>
+            </a:r>
+          </a:p>
+          <a:p>
+            <a:pPr marL="514350" indent="-514350">
+              <a:buAutoNum type="alphaLcParenR"/>
+            </a:pPr>
+            <a:r>
+              <a:rPr lang="en-US" dirty="0"/>
+              <a:t>Random processes</a:t>
+            </a:r>
+          </a:p>
+        </p:txBody>
+      </p:sp>
+      <p:sp>
+        <p:nvSpPr>
+          <p:cNvPr id="4" name="Slide Number Placeholder 3"/>
+          <p:cNvSpPr>
+            <a:spLocks noGrp="1"/>
+          </p:cNvSpPr>
+          <p:nvPr>
+            <p:ph type="sldNum" sz="quarter" idx="12"/>
+          </p:nvPr>
+        </p:nvSpPr>
+        <p:spPr/>
+        <p:txBody>
+          <a:bodyPr/>
+          <a:lstStyle/>
+          <a:p>
+            <a:pPr>
+              <a:defRPr/>
+            </a:pPr>
+            <a:fld id="{64137B81-8888-4253-92EC-0AED2A590749}" type="slidenum">
+              <a:rPr lang="en-US" smtClean="0"/>
+              <a:pPr>
+                <a:defRPr/>
+              </a:pPr>
+              <a:t>51</a:t>
+            </a:fld>
+            <a:endParaRPr lang="en-US"/>
+          </a:p>
+        </p:txBody>
+      </p:sp>
+    </p:spTree>
+    <p:extLst>
+      <p:ext uri="{BB962C8B-B14F-4D97-AF65-F5344CB8AC3E}">
+        <p14:creationId xmlns:p14="http://schemas.microsoft.com/office/powerpoint/2010/main" val="778798007"/>
+      </p:ext>
+    </p:extLst>
+  </p:cSld>
+  <p:clrMapOvr>
+    <a:masterClrMapping/>
+  </p:clrMapOvr>
+</p:sld>
+</file>
+
+<file path=ppt/slides/slide52.xml><?xml version="1.0" encoding="utf-8"?>
 <p:sld xmlns:a="http://schemas.openxmlformats.org/drawingml/2006/main" xmlns:r="http://schemas.openxmlformats.org/officeDocument/2006/relationships" xmlns:p="http://schemas.openxmlformats.org/presentationml/2006/main">
   <p:cSld>
     <p:spTree>
@@ -23380,7 +23551,7 @@
 </p:sld>
 </file>
 
-<file path=ppt/slides/slide51.xml><?xml version="1.0" encoding="utf-8"?>
+<file path=ppt/slides/slide53.xml><?xml version="1.0" encoding="utf-8"?>
 <p:sld xmlns:a="http://schemas.openxmlformats.org/drawingml/2006/main" xmlns:r="http://schemas.openxmlformats.org/officeDocument/2006/relationships" xmlns:p="http://schemas.openxmlformats.org/presentationml/2006/main">
   <p:cSld>
     <p:spTree>
@@ -23589,7 +23760,7 @@
 </p:sld>
 </file>
 
-<file path=ppt/slides/slide52.xml><?xml version="1.0" encoding="utf-8"?>
+<file path=ppt/slides/slide54.xml><?xml version="1.0" encoding="utf-8"?>
 <p:sld xmlns:a="http://schemas.openxmlformats.org/drawingml/2006/main" xmlns:r="http://schemas.openxmlformats.org/officeDocument/2006/relationships" xmlns:p="http://schemas.openxmlformats.org/presentationml/2006/main">
   <p:cSld>
     <p:spTree>
@@ -23858,7 +24029,7 @@
 </p:sld>
 </file>
 
-<file path=ppt/slides/slide53.xml><?xml version="1.0" encoding="utf-8"?>
+<file path=ppt/slides/slide55.xml><?xml version="1.0" encoding="utf-8"?>
 <p:sld xmlns:a="http://schemas.openxmlformats.org/drawingml/2006/main" xmlns:r="http://schemas.openxmlformats.org/officeDocument/2006/relationships" xmlns:p="http://schemas.openxmlformats.org/presentationml/2006/main">
   <p:cSld>
     <p:spTree>
@@ -24781,7 +24952,7 @@
 </p:sld>
 </file>
 
-<file path=ppt/slides/slide54.xml><?xml version="1.0" encoding="utf-8"?>
+<file path=ppt/slides/slide56.xml><?xml version="1.0" encoding="utf-8"?>
 <p:sld xmlns:a="http://schemas.openxmlformats.org/drawingml/2006/main" xmlns:r="http://schemas.openxmlformats.org/officeDocument/2006/relationships" xmlns:p="http://schemas.openxmlformats.org/presentationml/2006/main">
   <p:cSld>
     <p:spTree>
@@ -25778,7 +25949,7 @@
 </p:sld>
 </file>
 
-<file path=ppt/slides/slide55.xml><?xml version="1.0" encoding="utf-8"?>
+<file path=ppt/slides/slide57.xml><?xml version="1.0" encoding="utf-8"?>
 <p:sld xmlns:a="http://schemas.openxmlformats.org/drawingml/2006/main" xmlns:r="http://schemas.openxmlformats.org/officeDocument/2006/relationships" xmlns:p="http://schemas.openxmlformats.org/presentationml/2006/main">
   <p:cSld>
     <p:spTree>
@@ -27373,7 +27544,7 @@
 </p:sld>
 </file>
 
-<file path=ppt/slides/slide56.xml><?xml version="1.0" encoding="utf-8"?>
+<file path=ppt/slides/slide58.xml><?xml version="1.0" encoding="utf-8"?>
 <p:sld xmlns:a="http://schemas.openxmlformats.org/drawingml/2006/main" xmlns:r="http://schemas.openxmlformats.org/officeDocument/2006/relationships" xmlns:p="http://schemas.openxmlformats.org/presentationml/2006/main">
   <p:cSld>
     <p:spTree>
@@ -28370,7 +28541,7 @@
 </p:sld>
 </file>
 
-<file path=ppt/slides/slide57.xml><?xml version="1.0" encoding="utf-8"?>
+<file path=ppt/slides/slide59.xml><?xml version="1.0" encoding="utf-8"?>
 <p:sld xmlns:a="http://schemas.openxmlformats.org/drawingml/2006/main" xmlns:r="http://schemas.openxmlformats.org/officeDocument/2006/relationships" xmlns:p="http://schemas.openxmlformats.org/presentationml/2006/main">
   <p:cSld>
     <p:spTree>
@@ -29619,252 +29790,6 @@
 </p:sld>
 </file>
 
-<file path=ppt/slides/slide58.xml><?xml version="1.0" encoding="utf-8"?>
-<p:sld xmlns:a="http://schemas.openxmlformats.org/drawingml/2006/main" xmlns:r="http://schemas.openxmlformats.org/officeDocument/2006/relationships" xmlns:p="http://schemas.openxmlformats.org/presentationml/2006/main">
-  <p:cSld>
-    <p:spTree>
-      <p:nvGrpSpPr>
-        <p:cNvPr id="1" name=""/>
-        <p:cNvGrpSpPr/>
-        <p:nvPr/>
-      </p:nvGrpSpPr>
-      <p:grpSpPr>
-        <a:xfrm>
-          <a:off x="0" y="0"/>
-          <a:ext cx="0" cy="0"/>
-          <a:chOff x="0" y="0"/>
-          <a:chExt cx="0" cy="0"/>
-        </a:xfrm>
-      </p:grpSpPr>
-      <p:sp>
-        <p:nvSpPr>
-          <p:cNvPr id="586753" name="Title 1"/>
-          <p:cNvSpPr>
-            <a:spLocks noGrp="1"/>
-          </p:cNvSpPr>
-          <p:nvPr>
-            <p:ph type="title"/>
-          </p:nvPr>
-        </p:nvSpPr>
-        <p:spPr/>
-        <p:txBody>
-          <a:bodyPr/>
-          <a:lstStyle/>
-          <a:p>
-            <a:r>
-              <a:rPr lang="en-US" dirty="0"/>
-              <a:t>Question 223.8.3</a:t>
-            </a:r>
-          </a:p>
-        </p:txBody>
-      </p:sp>
-      <p:sp>
-        <p:nvSpPr>
-          <p:cNvPr id="3" name="Content Placeholder 2"/>
-          <p:cNvSpPr>
-            <a:spLocks noGrp="1"/>
-          </p:cNvSpPr>
-          <p:nvPr>
-            <p:ph idx="1"/>
-          </p:nvPr>
-        </p:nvSpPr>
-        <p:spPr/>
-        <p:txBody>
-          <a:bodyPr/>
-          <a:lstStyle/>
-          <a:p>
-            <a:pPr>
-              <a:buFontTx/>
-              <a:buNone/>
-              <a:defRPr/>
-            </a:pPr>
-            <a:r>
-              <a:rPr lang="en-US" dirty="0"/>
-              <a:t>I have two waves coming from speakers in my room. I am sitting 3 wavelengths away from one speaker and 4.5 wavelengths away from the other speaker. I hear..</a:t>
-            </a:r>
-          </a:p>
-          <a:p>
-            <a:pPr marL="514350" indent="-514350">
-              <a:buFontTx/>
-              <a:buAutoNum type="alphaLcParenR"/>
-              <a:defRPr/>
-            </a:pPr>
-            <a:r>
-              <a:rPr lang="en-US" dirty="0"/>
-              <a:t>Twice the normal loudness</a:t>
-            </a:r>
-          </a:p>
-          <a:p>
-            <a:pPr marL="514350" indent="-514350">
-              <a:buFontTx/>
-              <a:buAutoNum type="alphaLcParenR"/>
-              <a:defRPr/>
-            </a:pPr>
-            <a:r>
-              <a:rPr lang="en-US" dirty="0"/>
-              <a:t>4 times the normal loudness</a:t>
-            </a:r>
-          </a:p>
-          <a:p>
-            <a:pPr marL="514350" indent="-514350">
-              <a:buFontTx/>
-              <a:buAutoNum type="alphaLcParenR"/>
-              <a:defRPr/>
-            </a:pPr>
-            <a:r>
-              <a:rPr lang="en-US" dirty="0"/>
-              <a:t>8 times the normal loudness</a:t>
-            </a:r>
-          </a:p>
-          <a:p>
-            <a:pPr marL="514350" indent="-514350">
-              <a:buFontTx/>
-              <a:buAutoNum type="alphaLcParenR"/>
-              <a:defRPr/>
-            </a:pPr>
-            <a:r>
-              <a:rPr lang="en-US" dirty="0"/>
-              <a:t>Practically nothing</a:t>
-            </a:r>
-          </a:p>
-        </p:txBody>
-      </p:sp>
-    </p:spTree>
-    <p:extLst>
-      <p:ext uri="{BB962C8B-B14F-4D97-AF65-F5344CB8AC3E}">
-        <p14:creationId xmlns:p14="http://schemas.microsoft.com/office/powerpoint/2010/main" val="342519277"/>
-      </p:ext>
-    </p:extLst>
-  </p:cSld>
-  <p:clrMapOvr>
-    <a:masterClrMapping/>
-  </p:clrMapOvr>
-</p:sld>
-</file>
-
-<file path=ppt/slides/slide59.xml><?xml version="1.0" encoding="utf-8"?>
-<p:sld xmlns:a="http://schemas.openxmlformats.org/drawingml/2006/main" xmlns:r="http://schemas.openxmlformats.org/officeDocument/2006/relationships" xmlns:p="http://schemas.openxmlformats.org/presentationml/2006/main">
-  <p:cSld>
-    <p:spTree>
-      <p:nvGrpSpPr>
-        <p:cNvPr id="1" name=""/>
-        <p:cNvGrpSpPr/>
-        <p:nvPr/>
-      </p:nvGrpSpPr>
-      <p:grpSpPr>
-        <a:xfrm>
-          <a:off x="0" y="0"/>
-          <a:ext cx="0" cy="0"/>
-          <a:chOff x="0" y="0"/>
-          <a:chExt cx="0" cy="0"/>
-        </a:xfrm>
-      </p:grpSpPr>
-      <p:sp>
-        <p:nvSpPr>
-          <p:cNvPr id="587777" name="Title 1"/>
-          <p:cNvSpPr>
-            <a:spLocks noGrp="1"/>
-          </p:cNvSpPr>
-          <p:nvPr>
-            <p:ph type="title"/>
-          </p:nvPr>
-        </p:nvSpPr>
-        <p:spPr/>
-        <p:txBody>
-          <a:bodyPr/>
-          <a:lstStyle/>
-          <a:p>
-            <a:r>
-              <a:rPr lang="en-US" dirty="0"/>
-              <a:t>Question 223.8.4</a:t>
-            </a:r>
-          </a:p>
-        </p:txBody>
-      </p:sp>
-      <p:sp>
-        <p:nvSpPr>
-          <p:cNvPr id="3" name="Content Placeholder 2"/>
-          <p:cNvSpPr>
-            <a:spLocks noGrp="1"/>
-          </p:cNvSpPr>
-          <p:nvPr>
-            <p:ph idx="1"/>
-          </p:nvPr>
-        </p:nvSpPr>
-        <p:spPr/>
-        <p:txBody>
-          <a:bodyPr/>
-          <a:lstStyle/>
-          <a:p>
-            <a:pPr>
-              <a:buFontTx/>
-              <a:buNone/>
-              <a:defRPr/>
-            </a:pPr>
-            <a:r>
-              <a:rPr lang="en-US" dirty="0"/>
-              <a:t>I have two waves coming from speakers in my room. I am sitting 3 wavelengths away from one speaker and 6 wavelengths away from the other speaker. I hear..</a:t>
-            </a:r>
-          </a:p>
-          <a:p>
-            <a:pPr marL="514350" indent="-514350">
-              <a:buFontTx/>
-              <a:buAutoNum type="alphaLcParenR"/>
-              <a:defRPr/>
-            </a:pPr>
-            <a:r>
-              <a:rPr lang="en-US" dirty="0"/>
-              <a:t>Twice the normal loudness</a:t>
-            </a:r>
-          </a:p>
-          <a:p>
-            <a:pPr marL="514350" indent="-514350">
-              <a:buFontTx/>
-              <a:buAutoNum type="alphaLcParenR"/>
-              <a:defRPr/>
-            </a:pPr>
-            <a:r>
-              <a:rPr lang="en-US" dirty="0"/>
-              <a:t>4 times the normal loudness</a:t>
-            </a:r>
-          </a:p>
-          <a:p>
-            <a:pPr marL="514350" indent="-514350">
-              <a:buFontTx/>
-              <a:buAutoNum type="alphaLcParenR"/>
-              <a:defRPr/>
-            </a:pPr>
-            <a:r>
-              <a:rPr lang="en-US" dirty="0"/>
-              <a:t>8 times the normal loudness</a:t>
-            </a:r>
-          </a:p>
-          <a:p>
-            <a:pPr marL="514350" indent="-514350">
-              <a:buFontTx/>
-              <a:buAutoNum type="alphaLcParenR"/>
-              <a:defRPr/>
-            </a:pPr>
-            <a:r>
-              <a:rPr lang="en-US" dirty="0"/>
-              <a:t>Practically nothing</a:t>
-            </a:r>
-          </a:p>
-        </p:txBody>
-      </p:sp>
-    </p:spTree>
-    <p:extLst>
-      <p:ext uri="{BB962C8B-B14F-4D97-AF65-F5344CB8AC3E}">
-        <p14:creationId xmlns:p14="http://schemas.microsoft.com/office/powerpoint/2010/main" val="1990105726"/>
-      </p:ext>
-    </p:extLst>
-  </p:cSld>
-  <p:clrMapOvr>
-    <a:masterClrMapping/>
-  </p:clrMapOvr>
-</p:sld>
-</file>
-
 <file path=ppt/slides/slide6.xml><?xml version="1.0" encoding="utf-8"?>
 <p:sld xmlns:a="http://schemas.openxmlformats.org/drawingml/2006/main" xmlns:r="http://schemas.openxmlformats.org/officeDocument/2006/relationships" xmlns:p="http://schemas.openxmlformats.org/presentationml/2006/main">
   <p:cSld>
@@ -30014,6 +29939,252 @@
 </file>
 
 <file path=ppt/slides/slide60.xml><?xml version="1.0" encoding="utf-8"?>
+<p:sld xmlns:a="http://schemas.openxmlformats.org/drawingml/2006/main" xmlns:r="http://schemas.openxmlformats.org/officeDocument/2006/relationships" xmlns:p="http://schemas.openxmlformats.org/presentationml/2006/main">
+  <p:cSld>
+    <p:spTree>
+      <p:nvGrpSpPr>
+        <p:cNvPr id="1" name=""/>
+        <p:cNvGrpSpPr/>
+        <p:nvPr/>
+      </p:nvGrpSpPr>
+      <p:grpSpPr>
+        <a:xfrm>
+          <a:off x="0" y="0"/>
+          <a:ext cx="0" cy="0"/>
+          <a:chOff x="0" y="0"/>
+          <a:chExt cx="0" cy="0"/>
+        </a:xfrm>
+      </p:grpSpPr>
+      <p:sp>
+        <p:nvSpPr>
+          <p:cNvPr id="586753" name="Title 1"/>
+          <p:cNvSpPr>
+            <a:spLocks noGrp="1"/>
+          </p:cNvSpPr>
+          <p:nvPr>
+            <p:ph type="title"/>
+          </p:nvPr>
+        </p:nvSpPr>
+        <p:spPr/>
+        <p:txBody>
+          <a:bodyPr/>
+          <a:lstStyle/>
+          <a:p>
+            <a:r>
+              <a:rPr lang="en-US" dirty="0"/>
+              <a:t>Question 223.8.3</a:t>
+            </a:r>
+          </a:p>
+        </p:txBody>
+      </p:sp>
+      <p:sp>
+        <p:nvSpPr>
+          <p:cNvPr id="3" name="Content Placeholder 2"/>
+          <p:cNvSpPr>
+            <a:spLocks noGrp="1"/>
+          </p:cNvSpPr>
+          <p:nvPr>
+            <p:ph idx="1"/>
+          </p:nvPr>
+        </p:nvSpPr>
+        <p:spPr/>
+        <p:txBody>
+          <a:bodyPr/>
+          <a:lstStyle/>
+          <a:p>
+            <a:pPr>
+              <a:buFontTx/>
+              <a:buNone/>
+              <a:defRPr/>
+            </a:pPr>
+            <a:r>
+              <a:rPr lang="en-US" dirty="0"/>
+              <a:t>I have two waves coming from speakers in my room. I am sitting 3 wavelengths away from one speaker and 4.5 wavelengths away from the other speaker. I hear..</a:t>
+            </a:r>
+          </a:p>
+          <a:p>
+            <a:pPr marL="514350" indent="-514350">
+              <a:buFontTx/>
+              <a:buAutoNum type="alphaLcParenR"/>
+              <a:defRPr/>
+            </a:pPr>
+            <a:r>
+              <a:rPr lang="en-US" dirty="0"/>
+              <a:t>Twice the normal loudness</a:t>
+            </a:r>
+          </a:p>
+          <a:p>
+            <a:pPr marL="514350" indent="-514350">
+              <a:buFontTx/>
+              <a:buAutoNum type="alphaLcParenR"/>
+              <a:defRPr/>
+            </a:pPr>
+            <a:r>
+              <a:rPr lang="en-US" dirty="0"/>
+              <a:t>4 times the normal loudness</a:t>
+            </a:r>
+          </a:p>
+          <a:p>
+            <a:pPr marL="514350" indent="-514350">
+              <a:buFontTx/>
+              <a:buAutoNum type="alphaLcParenR"/>
+              <a:defRPr/>
+            </a:pPr>
+            <a:r>
+              <a:rPr lang="en-US" dirty="0"/>
+              <a:t>8 times the normal loudness</a:t>
+            </a:r>
+          </a:p>
+          <a:p>
+            <a:pPr marL="514350" indent="-514350">
+              <a:buFontTx/>
+              <a:buAutoNum type="alphaLcParenR"/>
+              <a:defRPr/>
+            </a:pPr>
+            <a:r>
+              <a:rPr lang="en-US" dirty="0"/>
+              <a:t>Practically nothing</a:t>
+            </a:r>
+          </a:p>
+        </p:txBody>
+      </p:sp>
+    </p:spTree>
+    <p:extLst>
+      <p:ext uri="{BB962C8B-B14F-4D97-AF65-F5344CB8AC3E}">
+        <p14:creationId xmlns:p14="http://schemas.microsoft.com/office/powerpoint/2010/main" val="342519277"/>
+      </p:ext>
+    </p:extLst>
+  </p:cSld>
+  <p:clrMapOvr>
+    <a:masterClrMapping/>
+  </p:clrMapOvr>
+</p:sld>
+</file>
+
+<file path=ppt/slides/slide61.xml><?xml version="1.0" encoding="utf-8"?>
+<p:sld xmlns:a="http://schemas.openxmlformats.org/drawingml/2006/main" xmlns:r="http://schemas.openxmlformats.org/officeDocument/2006/relationships" xmlns:p="http://schemas.openxmlformats.org/presentationml/2006/main">
+  <p:cSld>
+    <p:spTree>
+      <p:nvGrpSpPr>
+        <p:cNvPr id="1" name=""/>
+        <p:cNvGrpSpPr/>
+        <p:nvPr/>
+      </p:nvGrpSpPr>
+      <p:grpSpPr>
+        <a:xfrm>
+          <a:off x="0" y="0"/>
+          <a:ext cx="0" cy="0"/>
+          <a:chOff x="0" y="0"/>
+          <a:chExt cx="0" cy="0"/>
+        </a:xfrm>
+      </p:grpSpPr>
+      <p:sp>
+        <p:nvSpPr>
+          <p:cNvPr id="587777" name="Title 1"/>
+          <p:cNvSpPr>
+            <a:spLocks noGrp="1"/>
+          </p:cNvSpPr>
+          <p:nvPr>
+            <p:ph type="title"/>
+          </p:nvPr>
+        </p:nvSpPr>
+        <p:spPr/>
+        <p:txBody>
+          <a:bodyPr/>
+          <a:lstStyle/>
+          <a:p>
+            <a:r>
+              <a:rPr lang="en-US" dirty="0"/>
+              <a:t>Question 223.8.4</a:t>
+            </a:r>
+          </a:p>
+        </p:txBody>
+      </p:sp>
+      <p:sp>
+        <p:nvSpPr>
+          <p:cNvPr id="3" name="Content Placeholder 2"/>
+          <p:cNvSpPr>
+            <a:spLocks noGrp="1"/>
+          </p:cNvSpPr>
+          <p:nvPr>
+            <p:ph idx="1"/>
+          </p:nvPr>
+        </p:nvSpPr>
+        <p:spPr/>
+        <p:txBody>
+          <a:bodyPr/>
+          <a:lstStyle/>
+          <a:p>
+            <a:pPr>
+              <a:buFontTx/>
+              <a:buNone/>
+              <a:defRPr/>
+            </a:pPr>
+            <a:r>
+              <a:rPr lang="en-US" dirty="0"/>
+              <a:t>I have two waves coming from speakers in my room. I am sitting 3 wavelengths away from one speaker and 6 wavelengths away from the other speaker. I hear..</a:t>
+            </a:r>
+          </a:p>
+          <a:p>
+            <a:pPr marL="514350" indent="-514350">
+              <a:buFontTx/>
+              <a:buAutoNum type="alphaLcParenR"/>
+              <a:defRPr/>
+            </a:pPr>
+            <a:r>
+              <a:rPr lang="en-US" dirty="0"/>
+              <a:t>Twice the normal loudness</a:t>
+            </a:r>
+          </a:p>
+          <a:p>
+            <a:pPr marL="514350" indent="-514350">
+              <a:buFontTx/>
+              <a:buAutoNum type="alphaLcParenR"/>
+              <a:defRPr/>
+            </a:pPr>
+            <a:r>
+              <a:rPr lang="en-US" dirty="0"/>
+              <a:t>4 times the normal loudness</a:t>
+            </a:r>
+          </a:p>
+          <a:p>
+            <a:pPr marL="514350" indent="-514350">
+              <a:buFontTx/>
+              <a:buAutoNum type="alphaLcParenR"/>
+              <a:defRPr/>
+            </a:pPr>
+            <a:r>
+              <a:rPr lang="en-US" dirty="0"/>
+              <a:t>8 times the normal loudness</a:t>
+            </a:r>
+          </a:p>
+          <a:p>
+            <a:pPr marL="514350" indent="-514350">
+              <a:buFontTx/>
+              <a:buAutoNum type="alphaLcParenR"/>
+              <a:defRPr/>
+            </a:pPr>
+            <a:r>
+              <a:rPr lang="en-US" dirty="0"/>
+              <a:t>Practically nothing</a:t>
+            </a:r>
+          </a:p>
+        </p:txBody>
+      </p:sp>
+    </p:spTree>
+    <p:extLst>
+      <p:ext uri="{BB962C8B-B14F-4D97-AF65-F5344CB8AC3E}">
+        <p14:creationId xmlns:p14="http://schemas.microsoft.com/office/powerpoint/2010/main" val="1990105726"/>
+      </p:ext>
+    </p:extLst>
+  </p:cSld>
+  <p:clrMapOvr>
+    <a:masterClrMapping/>
+  </p:clrMapOvr>
+</p:sld>
+</file>
+
+<file path=ppt/slides/slide62.xml><?xml version="1.0" encoding="utf-8"?>
 <p:sld xmlns:a="http://schemas.openxmlformats.org/drawingml/2006/main" xmlns:r="http://schemas.openxmlformats.org/officeDocument/2006/relationships" xmlns:p="http://schemas.openxmlformats.org/presentationml/2006/main">
   <p:cSld>
     <p:spTree>
@@ -30772,7 +30943,7 @@
 </p:sld>
 </file>
 
-<file path=ppt/slides/slide61.xml><?xml version="1.0" encoding="utf-8"?>
+<file path=ppt/slides/slide63.xml><?xml version="1.0" encoding="utf-8"?>
 <p:sld xmlns:a="http://schemas.openxmlformats.org/drawingml/2006/main" xmlns:r="http://schemas.openxmlformats.org/officeDocument/2006/relationships" xmlns:p="http://schemas.openxmlformats.org/presentationml/2006/main">
   <p:cSld>
     <p:spTree>
@@ -30855,7 +31026,7 @@
 </p:sld>
 </file>
 
-<file path=ppt/slides/slide62.xml><?xml version="1.0" encoding="utf-8"?>
+<file path=ppt/slides/slide64.xml><?xml version="1.0" encoding="utf-8"?>
 <p:sld xmlns:a="http://schemas.openxmlformats.org/drawingml/2006/main" xmlns:r="http://schemas.openxmlformats.org/officeDocument/2006/relationships" xmlns:p="http://schemas.openxmlformats.org/presentationml/2006/main">
   <p:cSld>
     <p:spTree>
@@ -31227,7 +31398,7 @@
 </p:sld>
 </file>
 
-<file path=ppt/slides/slide63.xml><?xml version="1.0" encoding="utf-8"?>
+<file path=ppt/slides/slide65.xml><?xml version="1.0" encoding="utf-8"?>
 <p:sld xmlns:a="http://schemas.openxmlformats.org/drawingml/2006/main" xmlns:r="http://schemas.openxmlformats.org/officeDocument/2006/relationships" xmlns:p="http://schemas.openxmlformats.org/presentationml/2006/main">
   <p:cSld>
     <p:spTree>
@@ -31350,7 +31521,7 @@
               <a:pPr>
                 <a:defRPr/>
               </a:pPr>
-              <a:t>63</a:t>
+              <a:t>65</a:t>
             </a:fld>
             <a:endParaRPr lang="en-US"/>
           </a:p>
@@ -31369,7 +31540,7 @@
 </p:sld>
 </file>
 
-<file path=ppt/slides/slide64.xml><?xml version="1.0" encoding="utf-8"?>
+<file path=ppt/slides/slide66.xml><?xml version="1.0" encoding="utf-8"?>
 <p:sld xmlns:a="http://schemas.openxmlformats.org/drawingml/2006/main" xmlns:r="http://schemas.openxmlformats.org/officeDocument/2006/relationships" xmlns:p="http://schemas.openxmlformats.org/presentationml/2006/main">
   <p:cSld>
     <p:spTree>
@@ -31487,7 +31658,7 @@
 </p:sld>
 </file>
 
-<file path=ppt/slides/slide65.xml><?xml version="1.0" encoding="utf-8"?>
+<file path=ppt/slides/slide67.xml><?xml version="1.0" encoding="utf-8"?>
 <p:sld xmlns:a="http://schemas.openxmlformats.org/drawingml/2006/main" xmlns:r="http://schemas.openxmlformats.org/officeDocument/2006/relationships" xmlns:p="http://schemas.openxmlformats.org/presentationml/2006/main">
   <p:cSld>
     <p:spTree>
@@ -31625,7 +31796,7 @@
 </p:sld>
 </file>
 
-<file path=ppt/slides/slide66.xml><?xml version="1.0" encoding="utf-8"?>
+<file path=ppt/slides/slide68.xml><?xml version="1.0" encoding="utf-8"?>
 <p:sld xmlns:a="http://schemas.openxmlformats.org/drawingml/2006/main" xmlns:r="http://schemas.openxmlformats.org/officeDocument/2006/relationships" xmlns:p="http://schemas.openxmlformats.org/presentationml/2006/main">
   <p:cSld>
     <p:spTree>
@@ -31743,7 +31914,7 @@
 </p:sld>
 </file>
 
-<file path=ppt/slides/slide67.xml><?xml version="1.0" encoding="utf-8"?>
+<file path=ppt/slides/slide69.xml><?xml version="1.0" encoding="utf-8"?>
 <p:sld xmlns:a="http://schemas.openxmlformats.org/drawingml/2006/main" xmlns:r="http://schemas.openxmlformats.org/officeDocument/2006/relationships" xmlns:p="http://schemas.openxmlformats.org/presentationml/2006/main">
   <p:cSld>
     <p:spTree>
@@ -31862,250 +32033,6 @@
     <p:extLst>
       <p:ext uri="{BB962C8B-B14F-4D97-AF65-F5344CB8AC3E}">
         <p14:creationId xmlns:p14="http://schemas.microsoft.com/office/powerpoint/2010/main" val="3235514585"/>
-      </p:ext>
-    </p:extLst>
-  </p:cSld>
-  <p:clrMapOvr>
-    <a:masterClrMapping/>
-  </p:clrMapOvr>
-</p:sld>
-</file>
-
-<file path=ppt/slides/slide68.xml><?xml version="1.0" encoding="utf-8"?>
-<p:sld xmlns:a="http://schemas.openxmlformats.org/drawingml/2006/main" xmlns:r="http://schemas.openxmlformats.org/officeDocument/2006/relationships" xmlns:p="http://schemas.openxmlformats.org/presentationml/2006/main">
-  <p:cSld>
-    <p:spTree>
-      <p:nvGrpSpPr>
-        <p:cNvPr id="1" name=""/>
-        <p:cNvGrpSpPr/>
-        <p:nvPr/>
-      </p:nvGrpSpPr>
-      <p:grpSpPr>
-        <a:xfrm>
-          <a:off x="0" y="0"/>
-          <a:ext cx="0" cy="0"/>
-          <a:chOff x="0" y="0"/>
-          <a:chExt cx="0" cy="0"/>
-        </a:xfrm>
-      </p:grpSpPr>
-      <p:sp>
-        <p:nvSpPr>
-          <p:cNvPr id="548865" name="Title 1"/>
-          <p:cNvSpPr>
-            <a:spLocks noGrp="1"/>
-          </p:cNvSpPr>
-          <p:nvPr>
-            <p:ph type="title"/>
-          </p:nvPr>
-        </p:nvSpPr>
-        <p:spPr/>
-        <p:txBody>
-          <a:bodyPr>
-            <a:normAutofit/>
-          </a:bodyPr>
-          <a:lstStyle/>
-          <a:p>
-            <a:r>
-              <a:rPr lang="en-US" dirty="0"/>
-              <a:t>Question 223.4.14  123.22.10</a:t>
-            </a:r>
-          </a:p>
-        </p:txBody>
-      </p:sp>
-      <p:sp>
-        <p:nvSpPr>
-          <p:cNvPr id="548866" name="Content Placeholder 2"/>
-          <p:cNvSpPr>
-            <a:spLocks noGrp="1"/>
-          </p:cNvSpPr>
-          <p:nvPr>
-            <p:ph idx="1"/>
-          </p:nvPr>
-        </p:nvSpPr>
-        <p:spPr/>
-        <p:txBody>
-          <a:bodyPr>
-            <a:normAutofit lnSpcReduction="10000"/>
-          </a:bodyPr>
-          <a:lstStyle/>
-          <a:p>
-            <a:pPr>
-              <a:buFontTx/>
-              <a:buNone/>
-            </a:pPr>
-            <a:r>
-              <a:rPr lang="en-US" dirty="0"/>
-              <a:t>You are sitting in church. The speaker is talking into a microphone. The sound system radiates sound with a power of 50W . You are 20m  from the sound system output. What is the sound level? </a:t>
-            </a:r>
-          </a:p>
-          <a:p>
-            <a:pPr>
-              <a:buFontTx/>
-              <a:buNone/>
-            </a:pPr>
-            <a:r>
-              <a:rPr lang="en-US" b="1" dirty="0"/>
-              <a:t>a) 78dB</a:t>
-            </a:r>
-          </a:p>
-          <a:p>
-            <a:pPr>
-              <a:buFontTx/>
-              <a:buNone/>
-            </a:pPr>
-            <a:r>
-              <a:rPr lang="en-US" b="1" dirty="0"/>
-              <a:t>b) 80dB</a:t>
-            </a:r>
-          </a:p>
-          <a:p>
-            <a:pPr>
-              <a:buFontTx/>
-              <a:buNone/>
-            </a:pPr>
-            <a:r>
-              <a:rPr lang="en-US" b="1" dirty="0"/>
-              <a:t>c) 100dB</a:t>
-            </a:r>
-          </a:p>
-          <a:p>
-            <a:pPr>
-              <a:buFontTx/>
-              <a:buNone/>
-            </a:pPr>
-            <a:r>
-              <a:rPr lang="en-US" b="1" dirty="0"/>
-              <a:t>d) 120dB</a:t>
-            </a:r>
-          </a:p>
-        </p:txBody>
-      </p:sp>
-    </p:spTree>
-    <p:extLst>
-      <p:ext uri="{BB962C8B-B14F-4D97-AF65-F5344CB8AC3E}">
-        <p14:creationId xmlns:p14="http://schemas.microsoft.com/office/powerpoint/2010/main" val="1123963185"/>
-      </p:ext>
-    </p:extLst>
-  </p:cSld>
-  <p:clrMapOvr>
-    <a:masterClrMapping/>
-  </p:clrMapOvr>
-</p:sld>
-</file>
-
-<file path=ppt/slides/slide69.xml><?xml version="1.0" encoding="utf-8"?>
-<p:sld xmlns:a="http://schemas.openxmlformats.org/drawingml/2006/main" xmlns:r="http://schemas.openxmlformats.org/officeDocument/2006/relationships" xmlns:p="http://schemas.openxmlformats.org/presentationml/2006/main">
-  <p:cSld>
-    <p:spTree>
-      <p:nvGrpSpPr>
-        <p:cNvPr id="1" name=""/>
-        <p:cNvGrpSpPr/>
-        <p:nvPr/>
-      </p:nvGrpSpPr>
-      <p:grpSpPr>
-        <a:xfrm>
-          <a:off x="0" y="0"/>
-          <a:ext cx="0" cy="0"/>
-          <a:chOff x="0" y="0"/>
-          <a:chExt cx="0" cy="0"/>
-        </a:xfrm>
-      </p:grpSpPr>
-      <p:sp>
-        <p:nvSpPr>
-          <p:cNvPr id="549889" name="Title 1"/>
-          <p:cNvSpPr>
-            <a:spLocks noGrp="1"/>
-          </p:cNvSpPr>
-          <p:nvPr>
-            <p:ph type="title"/>
-          </p:nvPr>
-        </p:nvSpPr>
-        <p:spPr/>
-        <p:txBody>
-          <a:bodyPr>
-            <a:normAutofit fontScale="90000"/>
-          </a:bodyPr>
-          <a:lstStyle/>
-          <a:p>
-            <a:r>
-              <a:rPr lang="en-US" dirty="0"/>
-              <a:t>Question 223.4.15 GR 123.22.11 GR</a:t>
-            </a:r>
-          </a:p>
-        </p:txBody>
-      </p:sp>
-      <p:sp>
-        <p:nvSpPr>
-          <p:cNvPr id="549890" name="Content Placeholder 2"/>
-          <p:cNvSpPr>
-            <a:spLocks noGrp="1"/>
-          </p:cNvSpPr>
-          <p:nvPr>
-            <p:ph idx="1"/>
-          </p:nvPr>
-        </p:nvSpPr>
-        <p:spPr/>
-        <p:txBody>
-          <a:bodyPr>
-            <a:normAutofit fontScale="92500" lnSpcReduction="20000"/>
-          </a:bodyPr>
-          <a:lstStyle/>
-          <a:p>
-            <a:pPr>
-              <a:buFontTx/>
-              <a:buNone/>
-            </a:pPr>
-            <a:r>
-              <a:rPr lang="en-US" dirty="0"/>
-              <a:t>You are standing outside a Guns &amp; Roses Concert. The concert is in a stadium. You are 40 m from the stadium. You have a sound level meter with you and find that where you stand the sound level is 120dB. How much acoustic power are the “musicians” creating at their output location?</a:t>
-            </a:r>
-          </a:p>
-          <a:p>
-            <a:pPr>
-              <a:buFontTx/>
-              <a:buNone/>
-            </a:pPr>
-            <a:r>
-              <a:rPr lang="en-US" b="1" dirty="0"/>
-              <a:t>a) 78W</a:t>
-            </a:r>
-          </a:p>
-          <a:p>
-            <a:pPr>
-              <a:buFontTx/>
-              <a:buNone/>
-            </a:pPr>
-            <a:r>
-              <a:rPr lang="en-US" b="1" dirty="0"/>
-              <a:t>b) 134W</a:t>
-            </a:r>
-          </a:p>
-          <a:p>
-            <a:pPr>
-              <a:buFontTx/>
-              <a:buNone/>
-            </a:pPr>
-            <a:r>
-              <a:rPr lang="en-US" b="1" dirty="0"/>
-              <a:t>c) 545W</a:t>
-            </a:r>
-          </a:p>
-          <a:p>
-            <a:pPr>
-              <a:buFontTx/>
-              <a:buNone/>
-            </a:pPr>
-            <a:r>
-              <a:rPr lang="en-US" b="1" dirty="0"/>
-              <a:t>d) 20106W</a:t>
-            </a:r>
-          </a:p>
-        </p:txBody>
-      </p:sp>
-    </p:spTree>
-    <p:extLst>
-      <p:ext uri="{BB962C8B-B14F-4D97-AF65-F5344CB8AC3E}">
-        <p14:creationId xmlns:p14="http://schemas.microsoft.com/office/powerpoint/2010/main" val="3912737715"/>
       </p:ext>
     </p:extLst>
   </p:cSld>
@@ -33927,6 +33854,250 @@
       </p:grpSpPr>
       <p:sp>
         <p:nvSpPr>
+          <p:cNvPr id="548865" name="Title 1"/>
+          <p:cNvSpPr>
+            <a:spLocks noGrp="1"/>
+          </p:cNvSpPr>
+          <p:nvPr>
+            <p:ph type="title"/>
+          </p:nvPr>
+        </p:nvSpPr>
+        <p:spPr/>
+        <p:txBody>
+          <a:bodyPr>
+            <a:normAutofit/>
+          </a:bodyPr>
+          <a:lstStyle/>
+          <a:p>
+            <a:r>
+              <a:rPr lang="en-US" dirty="0"/>
+              <a:t>Question 223.4.14  123.22.10</a:t>
+            </a:r>
+          </a:p>
+        </p:txBody>
+      </p:sp>
+      <p:sp>
+        <p:nvSpPr>
+          <p:cNvPr id="548866" name="Content Placeholder 2"/>
+          <p:cNvSpPr>
+            <a:spLocks noGrp="1"/>
+          </p:cNvSpPr>
+          <p:nvPr>
+            <p:ph idx="1"/>
+          </p:nvPr>
+        </p:nvSpPr>
+        <p:spPr/>
+        <p:txBody>
+          <a:bodyPr>
+            <a:normAutofit lnSpcReduction="10000"/>
+          </a:bodyPr>
+          <a:lstStyle/>
+          <a:p>
+            <a:pPr>
+              <a:buFontTx/>
+              <a:buNone/>
+            </a:pPr>
+            <a:r>
+              <a:rPr lang="en-US" dirty="0"/>
+              <a:t>You are sitting in church. The speaker is talking into a microphone. The sound system radiates sound with a power of 50W . You are 20m  from the sound system output. What is the sound level? </a:t>
+            </a:r>
+          </a:p>
+          <a:p>
+            <a:pPr>
+              <a:buFontTx/>
+              <a:buNone/>
+            </a:pPr>
+            <a:r>
+              <a:rPr lang="en-US" b="1" dirty="0"/>
+              <a:t>a) 78dB</a:t>
+            </a:r>
+          </a:p>
+          <a:p>
+            <a:pPr>
+              <a:buFontTx/>
+              <a:buNone/>
+            </a:pPr>
+            <a:r>
+              <a:rPr lang="en-US" b="1" dirty="0"/>
+              <a:t>b) 80dB</a:t>
+            </a:r>
+          </a:p>
+          <a:p>
+            <a:pPr>
+              <a:buFontTx/>
+              <a:buNone/>
+            </a:pPr>
+            <a:r>
+              <a:rPr lang="en-US" b="1" dirty="0"/>
+              <a:t>c) 100dB</a:t>
+            </a:r>
+          </a:p>
+          <a:p>
+            <a:pPr>
+              <a:buFontTx/>
+              <a:buNone/>
+            </a:pPr>
+            <a:r>
+              <a:rPr lang="en-US" b="1" dirty="0"/>
+              <a:t>d) 120dB</a:t>
+            </a:r>
+          </a:p>
+        </p:txBody>
+      </p:sp>
+    </p:spTree>
+    <p:extLst>
+      <p:ext uri="{BB962C8B-B14F-4D97-AF65-F5344CB8AC3E}">
+        <p14:creationId xmlns:p14="http://schemas.microsoft.com/office/powerpoint/2010/main" val="1123963185"/>
+      </p:ext>
+    </p:extLst>
+  </p:cSld>
+  <p:clrMapOvr>
+    <a:masterClrMapping/>
+  </p:clrMapOvr>
+</p:sld>
+</file>
+
+<file path=ppt/slides/slide71.xml><?xml version="1.0" encoding="utf-8"?>
+<p:sld xmlns:a="http://schemas.openxmlformats.org/drawingml/2006/main" xmlns:r="http://schemas.openxmlformats.org/officeDocument/2006/relationships" xmlns:p="http://schemas.openxmlformats.org/presentationml/2006/main">
+  <p:cSld>
+    <p:spTree>
+      <p:nvGrpSpPr>
+        <p:cNvPr id="1" name=""/>
+        <p:cNvGrpSpPr/>
+        <p:nvPr/>
+      </p:nvGrpSpPr>
+      <p:grpSpPr>
+        <a:xfrm>
+          <a:off x="0" y="0"/>
+          <a:ext cx="0" cy="0"/>
+          <a:chOff x="0" y="0"/>
+          <a:chExt cx="0" cy="0"/>
+        </a:xfrm>
+      </p:grpSpPr>
+      <p:sp>
+        <p:nvSpPr>
+          <p:cNvPr id="549889" name="Title 1"/>
+          <p:cNvSpPr>
+            <a:spLocks noGrp="1"/>
+          </p:cNvSpPr>
+          <p:nvPr>
+            <p:ph type="title"/>
+          </p:nvPr>
+        </p:nvSpPr>
+        <p:spPr/>
+        <p:txBody>
+          <a:bodyPr>
+            <a:normAutofit fontScale="90000"/>
+          </a:bodyPr>
+          <a:lstStyle/>
+          <a:p>
+            <a:r>
+              <a:rPr lang="en-US" dirty="0"/>
+              <a:t>Question 223.4.15 GR 123.22.11 GR</a:t>
+            </a:r>
+          </a:p>
+        </p:txBody>
+      </p:sp>
+      <p:sp>
+        <p:nvSpPr>
+          <p:cNvPr id="549890" name="Content Placeholder 2"/>
+          <p:cNvSpPr>
+            <a:spLocks noGrp="1"/>
+          </p:cNvSpPr>
+          <p:nvPr>
+            <p:ph idx="1"/>
+          </p:nvPr>
+        </p:nvSpPr>
+        <p:spPr/>
+        <p:txBody>
+          <a:bodyPr>
+            <a:normAutofit fontScale="92500" lnSpcReduction="20000"/>
+          </a:bodyPr>
+          <a:lstStyle/>
+          <a:p>
+            <a:pPr>
+              <a:buFontTx/>
+              <a:buNone/>
+            </a:pPr>
+            <a:r>
+              <a:rPr lang="en-US" dirty="0"/>
+              <a:t>You are standing outside a Guns &amp; Roses Concert. The concert is in a stadium. You are 40 m from the stadium. You have a sound level meter with you and find that where you stand the sound level is 120dB. How much acoustic power are the “musicians” creating at their output location?</a:t>
+            </a:r>
+          </a:p>
+          <a:p>
+            <a:pPr>
+              <a:buFontTx/>
+              <a:buNone/>
+            </a:pPr>
+            <a:r>
+              <a:rPr lang="en-US" b="1" dirty="0"/>
+              <a:t>a) 78W</a:t>
+            </a:r>
+          </a:p>
+          <a:p>
+            <a:pPr>
+              <a:buFontTx/>
+              <a:buNone/>
+            </a:pPr>
+            <a:r>
+              <a:rPr lang="en-US" b="1" dirty="0"/>
+              <a:t>b) 134W</a:t>
+            </a:r>
+          </a:p>
+          <a:p>
+            <a:pPr>
+              <a:buFontTx/>
+              <a:buNone/>
+            </a:pPr>
+            <a:r>
+              <a:rPr lang="en-US" b="1" dirty="0"/>
+              <a:t>c) 545W</a:t>
+            </a:r>
+          </a:p>
+          <a:p>
+            <a:pPr>
+              <a:buFontTx/>
+              <a:buNone/>
+            </a:pPr>
+            <a:r>
+              <a:rPr lang="en-US" b="1" dirty="0"/>
+              <a:t>d) 20106W</a:t>
+            </a:r>
+          </a:p>
+        </p:txBody>
+      </p:sp>
+    </p:spTree>
+    <p:extLst>
+      <p:ext uri="{BB962C8B-B14F-4D97-AF65-F5344CB8AC3E}">
+        <p14:creationId xmlns:p14="http://schemas.microsoft.com/office/powerpoint/2010/main" val="3912737715"/>
+      </p:ext>
+    </p:extLst>
+  </p:cSld>
+  <p:clrMapOvr>
+    <a:masterClrMapping/>
+  </p:clrMapOvr>
+</p:sld>
+</file>
+
+<file path=ppt/slides/slide72.xml><?xml version="1.0" encoding="utf-8"?>
+<p:sld xmlns:a="http://schemas.openxmlformats.org/drawingml/2006/main" xmlns:r="http://schemas.openxmlformats.org/officeDocument/2006/relationships" xmlns:p="http://schemas.openxmlformats.org/presentationml/2006/main">
+  <p:cSld>
+    <p:spTree>
+      <p:nvGrpSpPr>
+        <p:cNvPr id="1" name=""/>
+        <p:cNvGrpSpPr/>
+        <p:nvPr/>
+      </p:nvGrpSpPr>
+      <p:grpSpPr>
+        <a:xfrm>
+          <a:off x="0" y="0"/>
+          <a:ext cx="0" cy="0"/>
+          <a:chOff x="0" y="0"/>
+          <a:chExt cx="0" cy="0"/>
+        </a:xfrm>
+      </p:grpSpPr>
+      <p:sp>
+        <p:nvSpPr>
           <p:cNvPr id="550913" name="Title 1"/>
           <p:cNvSpPr>
             <a:spLocks noGrp="1"/>
@@ -34028,7 +34199,7 @@
 </p:sld>
 </file>
 
-<file path=ppt/slides/slide71.xml><?xml version="1.0" encoding="utf-8"?>
+<file path=ppt/slides/slide73.xml><?xml version="1.0" encoding="utf-8"?>
 <p:sld xmlns:a="http://schemas.openxmlformats.org/drawingml/2006/main" xmlns:r="http://schemas.openxmlformats.org/officeDocument/2006/relationships" xmlns:p="http://schemas.openxmlformats.org/presentationml/2006/main">
   <p:cSld>
     <p:spTree>
@@ -34153,7 +34324,7 @@
 </p:sld>
 </file>
 
-<file path=ppt/slides/slide72.xml><?xml version="1.0" encoding="utf-8"?>
+<file path=ppt/slides/slide74.xml><?xml version="1.0" encoding="utf-8"?>
 <p:sld xmlns:a="http://schemas.openxmlformats.org/drawingml/2006/main" xmlns:r="http://schemas.openxmlformats.org/officeDocument/2006/relationships" xmlns:p="http://schemas.openxmlformats.org/presentationml/2006/main">
   <p:cSld>
     <p:spTree>
@@ -35212,7 +35383,7 @@
 </p:sld>
 </file>
 
-<file path=ppt/slides/slide73.xml><?xml version="1.0" encoding="utf-8"?>
+<file path=ppt/slides/slide75.xml><?xml version="1.0" encoding="utf-8"?>
 <p:sld xmlns:a="http://schemas.openxmlformats.org/drawingml/2006/main" xmlns:r="http://schemas.openxmlformats.org/officeDocument/2006/relationships" xmlns:p="http://schemas.openxmlformats.org/presentationml/2006/main">
   <p:cSld>
     <p:spTree>
@@ -35846,7 +36017,7 @@
 </p:sld>
 </file>
 
-<file path=ppt/slides/slide74.xml><?xml version="1.0" encoding="utf-8"?>
+<file path=ppt/slides/slide76.xml><?xml version="1.0" encoding="utf-8"?>
 <p:sld xmlns:a="http://schemas.openxmlformats.org/drawingml/2006/main" xmlns:r="http://schemas.openxmlformats.org/officeDocument/2006/relationships" xmlns:p="http://schemas.openxmlformats.org/presentationml/2006/main">
   <p:cSld>
     <p:spTree>
@@ -36255,7 +36426,7 @@
 </p:sld>
 </file>
 
-<file path=ppt/slides/slide75.xml><?xml version="1.0" encoding="utf-8"?>
+<file path=ppt/slides/slide77.xml><?xml version="1.0" encoding="utf-8"?>
 <p:sld xmlns:a="http://schemas.openxmlformats.org/drawingml/2006/main" xmlns:r="http://schemas.openxmlformats.org/officeDocument/2006/relationships" xmlns:p="http://schemas.openxmlformats.org/presentationml/2006/main">
   <p:cSld>
     <p:spTree>
@@ -36664,7 +36835,7 @@
 </p:sld>
 </file>
 
-<file path=ppt/slides/slide76.xml><?xml version="1.0" encoding="utf-8"?>
+<file path=ppt/slides/slide78.xml><?xml version="1.0" encoding="utf-8"?>
 <p:sld xmlns:a="http://schemas.openxmlformats.org/drawingml/2006/main" xmlns:r="http://schemas.openxmlformats.org/officeDocument/2006/relationships" xmlns:p="http://schemas.openxmlformats.org/presentationml/2006/main">
   <p:cSld>
     <p:spTree>
@@ -36816,7 +36987,7 @@
             <a:fld id="{23A722F0-04E0-4C85-BB4F-F38C170A22CE}" type="slidenum">
               <a:rPr lang="en-US" smtClean="0"/>
               <a:pPr/>
-              <a:t>76</a:t>
+              <a:t>78</a:t>
             </a:fld>
             <a:endParaRPr lang="en-US"/>
           </a:p>
@@ -36835,7 +37006,7 @@
 </p:sld>
 </file>
 
-<file path=ppt/slides/slide77.xml><?xml version="1.0" encoding="utf-8"?>
+<file path=ppt/slides/slide79.xml><?xml version="1.0" encoding="utf-8"?>
 <p:sld xmlns:a="http://schemas.openxmlformats.org/drawingml/2006/main" xmlns:r="http://schemas.openxmlformats.org/officeDocument/2006/relationships" xmlns:p="http://schemas.openxmlformats.org/presentationml/2006/main">
   <p:cSld>
     <p:spTree>
@@ -36953,301 +37124,6 @@
     <p:extLst>
       <p:ext uri="{BB962C8B-B14F-4D97-AF65-F5344CB8AC3E}">
         <p14:creationId xmlns:p14="http://schemas.microsoft.com/office/powerpoint/2010/main" val="2918768208"/>
-      </p:ext>
-    </p:extLst>
-  </p:cSld>
-  <p:clrMapOvr>
-    <a:masterClrMapping/>
-  </p:clrMapOvr>
-</p:sld>
-</file>
-
-<file path=ppt/slides/slide78.xml><?xml version="1.0" encoding="utf-8"?>
-<p:sld xmlns:a="http://schemas.openxmlformats.org/drawingml/2006/main" xmlns:r="http://schemas.openxmlformats.org/officeDocument/2006/relationships" xmlns:p="http://schemas.openxmlformats.org/presentationml/2006/main">
-  <p:cSld>
-    <p:spTree>
-      <p:nvGrpSpPr>
-        <p:cNvPr id="1" name=""/>
-        <p:cNvGrpSpPr/>
-        <p:nvPr/>
-      </p:nvGrpSpPr>
-      <p:grpSpPr>
-        <a:xfrm>
-          <a:off x="0" y="0"/>
-          <a:ext cx="0" cy="0"/>
-          <a:chOff x="0" y="0"/>
-          <a:chExt cx="0" cy="0"/>
-        </a:xfrm>
-      </p:grpSpPr>
-      <p:sp>
-        <p:nvSpPr>
-          <p:cNvPr id="69635" name="Rectangle 2"/>
-          <p:cNvSpPr>
-            <a:spLocks noGrp="1" noChangeArrowheads="1"/>
-          </p:cNvSpPr>
-          <p:nvPr>
-            <p:ph type="title"/>
-          </p:nvPr>
-        </p:nvSpPr>
-        <p:spPr/>
-        <p:txBody>
-          <a:bodyPr/>
-          <a:lstStyle/>
-          <a:p>
-            <a:pPr eaLnBrk="1" hangingPunct="1"/>
-            <a:r>
-              <a:rPr lang="en-US" dirty="0"/>
-              <a:t>Question 225.5.4</a:t>
-            </a:r>
-          </a:p>
-        </p:txBody>
-      </p:sp>
-      <p:sp>
-        <p:nvSpPr>
-          <p:cNvPr id="69636" name="Rectangle 3"/>
-          <p:cNvSpPr>
-            <a:spLocks noGrp="1" noChangeArrowheads="1"/>
-          </p:cNvSpPr>
-          <p:nvPr>
-            <p:ph idx="1"/>
-          </p:nvPr>
-        </p:nvSpPr>
-        <p:spPr/>
-        <p:txBody>
-          <a:bodyPr/>
-          <a:lstStyle/>
-          <a:p>
-            <a:pPr marL="609600" indent="-609600" eaLnBrk="1" hangingPunct="1">
-              <a:lnSpc>
-                <a:spcPct val="90000"/>
-              </a:lnSpc>
-              <a:buFontTx/>
-              <a:buNone/>
-            </a:pPr>
-            <a:r>
-              <a:rPr lang="en-US" dirty="0"/>
-              <a:t>Often a single jet will create two sonic booms, why?</a:t>
-            </a:r>
-          </a:p>
-          <a:p>
-            <a:pPr marL="609600" indent="-609600" eaLnBrk="1" hangingPunct="1">
-              <a:lnSpc>
-                <a:spcPct val="90000"/>
-              </a:lnSpc>
-              <a:buFontTx/>
-              <a:buAutoNum type="alphaLcParenR"/>
-            </a:pPr>
-            <a:r>
-              <a:rPr lang="en-US" dirty="0"/>
-              <a:t>One is from the plane and one is from the condensation trail that follows the plane</a:t>
-            </a:r>
-          </a:p>
-          <a:p>
-            <a:pPr marL="609600" indent="-609600" eaLnBrk="1" hangingPunct="1">
-              <a:lnSpc>
-                <a:spcPct val="90000"/>
-              </a:lnSpc>
-              <a:buFontTx/>
-              <a:buAutoNum type="alphaLcParenR"/>
-            </a:pPr>
-            <a:r>
-              <a:rPr lang="en-US" dirty="0"/>
-              <a:t>The nose and the tail both act as wave sources</a:t>
-            </a:r>
-          </a:p>
-          <a:p>
-            <a:pPr marL="609600" indent="-609600" eaLnBrk="1" hangingPunct="1">
-              <a:lnSpc>
-                <a:spcPct val="90000"/>
-              </a:lnSpc>
-              <a:buFontTx/>
-              <a:buAutoNum type="alphaLcParenR"/>
-            </a:pPr>
-            <a:r>
-              <a:rPr lang="en-US" dirty="0"/>
-              <a:t>One is from the plane and one is a Newton's third law reaction</a:t>
-            </a:r>
-          </a:p>
-        </p:txBody>
-      </p:sp>
-      <p:sp>
-        <p:nvSpPr>
-          <p:cNvPr id="69634" name="Slide Number Placeholder 5"/>
-          <p:cNvSpPr>
-            <a:spLocks noGrp="1"/>
-          </p:cNvSpPr>
-          <p:nvPr>
-            <p:ph type="sldNum" sz="quarter" idx="12"/>
-          </p:nvPr>
-        </p:nvSpPr>
-        <p:spPr>
-          <a:noFill/>
-        </p:spPr>
-        <p:txBody>
-          <a:bodyPr/>
-          <a:lstStyle/>
-          <a:p>
-            <a:fld id="{0444647A-B62D-46AC-8BB6-871103D5B2E6}" type="slidenum">
-              <a:rPr lang="en-US" smtClean="0"/>
-              <a:pPr/>
-              <a:t>78</a:t>
-            </a:fld>
-            <a:endParaRPr lang="en-US"/>
-          </a:p>
-        </p:txBody>
-      </p:sp>
-    </p:spTree>
-    <p:extLst>
-      <p:ext uri="{BB962C8B-B14F-4D97-AF65-F5344CB8AC3E}">
-        <p14:creationId xmlns:p14="http://schemas.microsoft.com/office/powerpoint/2010/main" val="2700378708"/>
-      </p:ext>
-    </p:extLst>
-  </p:cSld>
-  <p:clrMapOvr>
-    <a:masterClrMapping/>
-  </p:clrMapOvr>
-</p:sld>
-</file>
-
-<file path=ppt/slides/slide79.xml><?xml version="1.0" encoding="utf-8"?>
-<p:sld xmlns:a="http://schemas.openxmlformats.org/drawingml/2006/main" xmlns:r="http://schemas.openxmlformats.org/officeDocument/2006/relationships" xmlns:p="http://schemas.openxmlformats.org/presentationml/2006/main">
-  <p:cSld>
-    <p:spTree>
-      <p:nvGrpSpPr>
-        <p:cNvPr id="1" name=""/>
-        <p:cNvGrpSpPr/>
-        <p:nvPr/>
-      </p:nvGrpSpPr>
-      <p:grpSpPr>
-        <a:xfrm>
-          <a:off x="0" y="0"/>
-          <a:ext cx="0" cy="0"/>
-          <a:chOff x="0" y="0"/>
-          <a:chExt cx="0" cy="0"/>
-        </a:xfrm>
-      </p:grpSpPr>
-      <p:sp>
-        <p:nvSpPr>
-          <p:cNvPr id="2" name="Title 1"/>
-          <p:cNvSpPr>
-            <a:spLocks noGrp="1"/>
-          </p:cNvSpPr>
-          <p:nvPr>
-            <p:ph type="title"/>
-          </p:nvPr>
-        </p:nvSpPr>
-        <p:spPr/>
-        <p:txBody>
-          <a:bodyPr/>
-          <a:lstStyle/>
-          <a:p>
-            <a:r>
-              <a:rPr lang="en-US" dirty="0"/>
-              <a:t>Question 223.5.4.1</a:t>
-            </a:r>
-          </a:p>
-        </p:txBody>
-      </p:sp>
-      <p:sp>
-        <p:nvSpPr>
-          <p:cNvPr id="3" name="Content Placeholder 2"/>
-          <p:cNvSpPr>
-            <a:spLocks noGrp="1"/>
-          </p:cNvSpPr>
-          <p:nvPr>
-            <p:ph idx="1"/>
-          </p:nvPr>
-        </p:nvSpPr>
-        <p:spPr/>
-        <p:txBody>
-          <a:bodyPr/>
-          <a:lstStyle/>
-          <a:p>
-            <a:pPr marL="0" indent="0">
-              <a:buNone/>
-            </a:pPr>
-            <a:r>
-              <a:rPr lang="en-US" dirty="0"/>
-              <a:t>You are playing your Irish tin whistle at 440Hz. Your friend runs toward you at 10m/s. What frequency does your friend hear? (take 343m.s as the speed of sound)</a:t>
-            </a:r>
-          </a:p>
-          <a:p>
-            <a:pPr marL="514350" indent="-514350">
-              <a:buAutoNum type="alphaLcParenR"/>
-            </a:pPr>
-            <a:r>
-              <a:rPr lang="en-US" dirty="0"/>
-              <a:t>453.8Hz</a:t>
-            </a:r>
-          </a:p>
-          <a:p>
-            <a:pPr marL="514350" indent="-514350">
-              <a:buAutoNum type="alphaLcParenR"/>
-            </a:pPr>
-            <a:r>
-              <a:rPr lang="en-US" dirty="0"/>
-              <a:t>427.1Hz</a:t>
-            </a:r>
-          </a:p>
-          <a:p>
-            <a:pPr marL="514350" indent="-514350">
-              <a:buAutoNum type="alphaLcParenR"/>
-            </a:pPr>
-            <a:r>
-              <a:rPr lang="en-US" dirty="0"/>
-              <a:t>453.2</a:t>
-            </a:r>
-          </a:p>
-          <a:p>
-            <a:pPr marL="514350" indent="-514350">
-              <a:buAutoNum type="alphaLcParenR"/>
-            </a:pPr>
-            <a:r>
-              <a:rPr lang="en-US" dirty="0"/>
-              <a:t>427.5</a:t>
-            </a:r>
-          </a:p>
-          <a:p>
-            <a:pPr marL="0" indent="0">
-              <a:buNone/>
-            </a:pPr>
-            <a:endParaRPr lang="en-US" dirty="0"/>
-          </a:p>
-        </p:txBody>
-      </p:sp>
-      <p:sp>
-        <p:nvSpPr>
-          <p:cNvPr id="4" name="Slide Number Placeholder 3"/>
-          <p:cNvSpPr>
-            <a:spLocks noGrp="1"/>
-          </p:cNvSpPr>
-          <p:nvPr>
-            <p:ph type="sldNum" sz="quarter" idx="12"/>
-          </p:nvPr>
-        </p:nvSpPr>
-        <p:spPr/>
-        <p:txBody>
-          <a:bodyPr/>
-          <a:lstStyle/>
-          <a:p>
-            <a:pPr>
-              <a:defRPr/>
-            </a:pPr>
-            <a:fld id="{64137B81-8888-4253-92EC-0AED2A590749}" type="slidenum">
-              <a:rPr lang="en-US" smtClean="0"/>
-              <a:pPr>
-                <a:defRPr/>
-              </a:pPr>
-              <a:t>79</a:t>
-            </a:fld>
-            <a:endParaRPr lang="en-US"/>
-          </a:p>
-        </p:txBody>
-      </p:sp>
-    </p:spTree>
-    <p:extLst>
-      <p:ext uri="{BB962C8B-B14F-4D97-AF65-F5344CB8AC3E}">
-        <p14:creationId xmlns:p14="http://schemas.microsoft.com/office/powerpoint/2010/main" val="4011188011"/>
       </p:ext>
     </p:extLst>
   </p:cSld>
@@ -37886,6 +37762,301 @@
 </file>
 
 <file path=ppt/slides/slide80.xml><?xml version="1.0" encoding="utf-8"?>
+<p:sld xmlns:a="http://schemas.openxmlformats.org/drawingml/2006/main" xmlns:r="http://schemas.openxmlformats.org/officeDocument/2006/relationships" xmlns:p="http://schemas.openxmlformats.org/presentationml/2006/main">
+  <p:cSld>
+    <p:spTree>
+      <p:nvGrpSpPr>
+        <p:cNvPr id="1" name=""/>
+        <p:cNvGrpSpPr/>
+        <p:nvPr/>
+      </p:nvGrpSpPr>
+      <p:grpSpPr>
+        <a:xfrm>
+          <a:off x="0" y="0"/>
+          <a:ext cx="0" cy="0"/>
+          <a:chOff x="0" y="0"/>
+          <a:chExt cx="0" cy="0"/>
+        </a:xfrm>
+      </p:grpSpPr>
+      <p:sp>
+        <p:nvSpPr>
+          <p:cNvPr id="69635" name="Rectangle 2"/>
+          <p:cNvSpPr>
+            <a:spLocks noGrp="1" noChangeArrowheads="1"/>
+          </p:cNvSpPr>
+          <p:nvPr>
+            <p:ph type="title"/>
+          </p:nvPr>
+        </p:nvSpPr>
+        <p:spPr/>
+        <p:txBody>
+          <a:bodyPr/>
+          <a:lstStyle/>
+          <a:p>
+            <a:pPr eaLnBrk="1" hangingPunct="1"/>
+            <a:r>
+              <a:rPr lang="en-US" dirty="0"/>
+              <a:t>Question 225.5.4</a:t>
+            </a:r>
+          </a:p>
+        </p:txBody>
+      </p:sp>
+      <p:sp>
+        <p:nvSpPr>
+          <p:cNvPr id="69636" name="Rectangle 3"/>
+          <p:cNvSpPr>
+            <a:spLocks noGrp="1" noChangeArrowheads="1"/>
+          </p:cNvSpPr>
+          <p:nvPr>
+            <p:ph idx="1"/>
+          </p:nvPr>
+        </p:nvSpPr>
+        <p:spPr/>
+        <p:txBody>
+          <a:bodyPr/>
+          <a:lstStyle/>
+          <a:p>
+            <a:pPr marL="609600" indent="-609600" eaLnBrk="1" hangingPunct="1">
+              <a:lnSpc>
+                <a:spcPct val="90000"/>
+              </a:lnSpc>
+              <a:buFontTx/>
+              <a:buNone/>
+            </a:pPr>
+            <a:r>
+              <a:rPr lang="en-US" dirty="0"/>
+              <a:t>Often a single jet will create two sonic booms, why?</a:t>
+            </a:r>
+          </a:p>
+          <a:p>
+            <a:pPr marL="609600" indent="-609600" eaLnBrk="1" hangingPunct="1">
+              <a:lnSpc>
+                <a:spcPct val="90000"/>
+              </a:lnSpc>
+              <a:buFontTx/>
+              <a:buAutoNum type="alphaLcParenR"/>
+            </a:pPr>
+            <a:r>
+              <a:rPr lang="en-US" dirty="0"/>
+              <a:t>One is from the plane and one is from the condensation trail that follows the plane</a:t>
+            </a:r>
+          </a:p>
+          <a:p>
+            <a:pPr marL="609600" indent="-609600" eaLnBrk="1" hangingPunct="1">
+              <a:lnSpc>
+                <a:spcPct val="90000"/>
+              </a:lnSpc>
+              <a:buFontTx/>
+              <a:buAutoNum type="alphaLcParenR"/>
+            </a:pPr>
+            <a:r>
+              <a:rPr lang="en-US" dirty="0"/>
+              <a:t>The nose and the tail both act as wave sources</a:t>
+            </a:r>
+          </a:p>
+          <a:p>
+            <a:pPr marL="609600" indent="-609600" eaLnBrk="1" hangingPunct="1">
+              <a:lnSpc>
+                <a:spcPct val="90000"/>
+              </a:lnSpc>
+              <a:buFontTx/>
+              <a:buAutoNum type="alphaLcParenR"/>
+            </a:pPr>
+            <a:r>
+              <a:rPr lang="en-US" dirty="0"/>
+              <a:t>One is from the plane and one is a Newton's third law reaction</a:t>
+            </a:r>
+          </a:p>
+        </p:txBody>
+      </p:sp>
+      <p:sp>
+        <p:nvSpPr>
+          <p:cNvPr id="69634" name="Slide Number Placeholder 5"/>
+          <p:cNvSpPr>
+            <a:spLocks noGrp="1"/>
+          </p:cNvSpPr>
+          <p:nvPr>
+            <p:ph type="sldNum" sz="quarter" idx="12"/>
+          </p:nvPr>
+        </p:nvSpPr>
+        <p:spPr>
+          <a:noFill/>
+        </p:spPr>
+        <p:txBody>
+          <a:bodyPr/>
+          <a:lstStyle/>
+          <a:p>
+            <a:fld id="{0444647A-B62D-46AC-8BB6-871103D5B2E6}" type="slidenum">
+              <a:rPr lang="en-US" smtClean="0"/>
+              <a:pPr/>
+              <a:t>80</a:t>
+            </a:fld>
+            <a:endParaRPr lang="en-US"/>
+          </a:p>
+        </p:txBody>
+      </p:sp>
+    </p:spTree>
+    <p:extLst>
+      <p:ext uri="{BB962C8B-B14F-4D97-AF65-F5344CB8AC3E}">
+        <p14:creationId xmlns:p14="http://schemas.microsoft.com/office/powerpoint/2010/main" val="2700378708"/>
+      </p:ext>
+    </p:extLst>
+  </p:cSld>
+  <p:clrMapOvr>
+    <a:masterClrMapping/>
+  </p:clrMapOvr>
+</p:sld>
+</file>
+
+<file path=ppt/slides/slide81.xml><?xml version="1.0" encoding="utf-8"?>
+<p:sld xmlns:a="http://schemas.openxmlformats.org/drawingml/2006/main" xmlns:r="http://schemas.openxmlformats.org/officeDocument/2006/relationships" xmlns:p="http://schemas.openxmlformats.org/presentationml/2006/main">
+  <p:cSld>
+    <p:spTree>
+      <p:nvGrpSpPr>
+        <p:cNvPr id="1" name=""/>
+        <p:cNvGrpSpPr/>
+        <p:nvPr/>
+      </p:nvGrpSpPr>
+      <p:grpSpPr>
+        <a:xfrm>
+          <a:off x="0" y="0"/>
+          <a:ext cx="0" cy="0"/>
+          <a:chOff x="0" y="0"/>
+          <a:chExt cx="0" cy="0"/>
+        </a:xfrm>
+      </p:grpSpPr>
+      <p:sp>
+        <p:nvSpPr>
+          <p:cNvPr id="2" name="Title 1"/>
+          <p:cNvSpPr>
+            <a:spLocks noGrp="1"/>
+          </p:cNvSpPr>
+          <p:nvPr>
+            <p:ph type="title"/>
+          </p:nvPr>
+        </p:nvSpPr>
+        <p:spPr/>
+        <p:txBody>
+          <a:bodyPr/>
+          <a:lstStyle/>
+          <a:p>
+            <a:r>
+              <a:rPr lang="en-US" dirty="0"/>
+              <a:t>Question 223.5.4.1</a:t>
+            </a:r>
+          </a:p>
+        </p:txBody>
+      </p:sp>
+      <p:sp>
+        <p:nvSpPr>
+          <p:cNvPr id="3" name="Content Placeholder 2"/>
+          <p:cNvSpPr>
+            <a:spLocks noGrp="1"/>
+          </p:cNvSpPr>
+          <p:nvPr>
+            <p:ph idx="1"/>
+          </p:nvPr>
+        </p:nvSpPr>
+        <p:spPr/>
+        <p:txBody>
+          <a:bodyPr/>
+          <a:lstStyle/>
+          <a:p>
+            <a:pPr marL="0" indent="0">
+              <a:buNone/>
+            </a:pPr>
+            <a:r>
+              <a:rPr lang="en-US" dirty="0"/>
+              <a:t>You are playing your Irish tin whistle at 440Hz. Your friend runs toward you at 10m/s. What frequency does your friend hear? (take 343m.s as the speed of sound)</a:t>
+            </a:r>
+          </a:p>
+          <a:p>
+            <a:pPr marL="514350" indent="-514350">
+              <a:buAutoNum type="alphaLcParenR"/>
+            </a:pPr>
+            <a:r>
+              <a:rPr lang="en-US" dirty="0"/>
+              <a:t>453.8Hz</a:t>
+            </a:r>
+          </a:p>
+          <a:p>
+            <a:pPr marL="514350" indent="-514350">
+              <a:buAutoNum type="alphaLcParenR"/>
+            </a:pPr>
+            <a:r>
+              <a:rPr lang="en-US" dirty="0"/>
+              <a:t>427.1Hz</a:t>
+            </a:r>
+          </a:p>
+          <a:p>
+            <a:pPr marL="514350" indent="-514350">
+              <a:buAutoNum type="alphaLcParenR"/>
+            </a:pPr>
+            <a:r>
+              <a:rPr lang="en-US" dirty="0"/>
+              <a:t>453.2</a:t>
+            </a:r>
+          </a:p>
+          <a:p>
+            <a:pPr marL="514350" indent="-514350">
+              <a:buAutoNum type="alphaLcParenR"/>
+            </a:pPr>
+            <a:r>
+              <a:rPr lang="en-US" dirty="0"/>
+              <a:t>427.5</a:t>
+            </a:r>
+          </a:p>
+          <a:p>
+            <a:pPr marL="0" indent="0">
+              <a:buNone/>
+            </a:pPr>
+            <a:endParaRPr lang="en-US" dirty="0"/>
+          </a:p>
+        </p:txBody>
+      </p:sp>
+      <p:sp>
+        <p:nvSpPr>
+          <p:cNvPr id="4" name="Slide Number Placeholder 3"/>
+          <p:cNvSpPr>
+            <a:spLocks noGrp="1"/>
+          </p:cNvSpPr>
+          <p:nvPr>
+            <p:ph type="sldNum" sz="quarter" idx="12"/>
+          </p:nvPr>
+        </p:nvSpPr>
+        <p:spPr/>
+        <p:txBody>
+          <a:bodyPr/>
+          <a:lstStyle/>
+          <a:p>
+            <a:pPr>
+              <a:defRPr/>
+            </a:pPr>
+            <a:fld id="{64137B81-8888-4253-92EC-0AED2A590749}" type="slidenum">
+              <a:rPr lang="en-US" smtClean="0"/>
+              <a:pPr>
+                <a:defRPr/>
+              </a:pPr>
+              <a:t>81</a:t>
+            </a:fld>
+            <a:endParaRPr lang="en-US"/>
+          </a:p>
+        </p:txBody>
+      </p:sp>
+    </p:spTree>
+    <p:extLst>
+      <p:ext uri="{BB962C8B-B14F-4D97-AF65-F5344CB8AC3E}">
+        <p14:creationId xmlns:p14="http://schemas.microsoft.com/office/powerpoint/2010/main" val="4011188011"/>
+      </p:ext>
+    </p:extLst>
+  </p:cSld>
+  <p:clrMapOvr>
+    <a:masterClrMapping/>
+  </p:clrMapOvr>
+</p:sld>
+</file>
+
+<file path=ppt/slides/slide82.xml><?xml version="1.0" encoding="utf-8"?>
 <p:sld xmlns:a="http://schemas.openxmlformats.org/drawingml/2006/main" xmlns:r="http://schemas.openxmlformats.org/officeDocument/2006/relationships" xmlns:p="http://schemas.openxmlformats.org/presentationml/2006/main">
   <p:cSld>
     <p:spTree>
@@ -39275,7 +39446,7 @@
 </p:sld>
 </file>
 
-<file path=ppt/slides/slide81.xml><?xml version="1.0" encoding="utf-8"?>
+<file path=ppt/slides/slide83.xml><?xml version="1.0" encoding="utf-8"?>
 <p:sld xmlns:a="http://schemas.openxmlformats.org/drawingml/2006/main" xmlns:r="http://schemas.openxmlformats.org/officeDocument/2006/relationships" xmlns:p="http://schemas.openxmlformats.org/presentationml/2006/main">
   <p:cSld>
     <p:spTree>
@@ -39344,7 +39515,7 @@
 </p:sld>
 </file>
 
-<file path=ppt/slides/slide82.xml><?xml version="1.0" encoding="utf-8"?>
+<file path=ppt/slides/slide84.xml><?xml version="1.0" encoding="utf-8"?>
 <p:sld xmlns:a="http://schemas.openxmlformats.org/drawingml/2006/main" xmlns:r="http://schemas.openxmlformats.org/officeDocument/2006/relationships" xmlns:p="http://schemas.openxmlformats.org/presentationml/2006/main">
   <p:cSld>
     <p:spTree>
@@ -39453,7 +39624,7 @@
 </p:sld>
 </file>
 
-<file path=ppt/slides/slide83.xml><?xml version="1.0" encoding="utf-8"?>
+<file path=ppt/slides/slide85.xml><?xml version="1.0" encoding="utf-8"?>
 <p:sld xmlns:a="http://schemas.openxmlformats.org/drawingml/2006/main" xmlns:r="http://schemas.openxmlformats.org/officeDocument/2006/relationships" xmlns:p="http://schemas.openxmlformats.org/presentationml/2006/main">
   <p:cSld>
     <p:spTree>
@@ -39509,7 +39680,7 @@
 </p:sld>
 </file>
 
-<file path=ppt/slides/slide84.xml><?xml version="1.0" encoding="utf-8"?>
+<file path=ppt/slides/slide86.xml><?xml version="1.0" encoding="utf-8"?>
 <p:sld xmlns:a="http://schemas.openxmlformats.org/drawingml/2006/main" xmlns:r="http://schemas.openxmlformats.org/officeDocument/2006/relationships" xmlns:p="http://schemas.openxmlformats.org/presentationml/2006/main">
   <p:cSld>
     <p:spTree>
@@ -39629,7 +39800,7 @@
 </p:sld>
 </file>
 
-<file path=ppt/slides/slide85.xml><?xml version="1.0" encoding="utf-8"?>
+<file path=ppt/slides/slide87.xml><?xml version="1.0" encoding="utf-8"?>
 <p:sld xmlns:a="http://schemas.openxmlformats.org/drawingml/2006/main" xmlns:r="http://schemas.openxmlformats.org/officeDocument/2006/relationships" xmlns:p="http://schemas.openxmlformats.org/presentationml/2006/main">
   <p:cSld>
     <p:spTree>
@@ -39753,7 +39924,7 @@
 </p:sld>
 </file>
 
-<file path=ppt/slides/slide86.xml><?xml version="1.0" encoding="utf-8"?>
+<file path=ppt/slides/slide88.xml><?xml version="1.0" encoding="utf-8"?>
 <p:sld xmlns:a="http://schemas.openxmlformats.org/drawingml/2006/main" xmlns:r="http://schemas.openxmlformats.org/officeDocument/2006/relationships" xmlns:p="http://schemas.openxmlformats.org/presentationml/2006/main">
   <p:cSld>
     <p:spTree>

</xml_diff>